<commit_message>
Update O/X 서바이벌 assets and add ZIP slides
Co-Authored-By: Claude Opus 4.6 (1M context) <noreply@anthropic.com>
</commit_message>
<xml_diff>
--- a/public/downloads/games/ox-survival/rules.pptx
+++ b/public/downloads/games/ox-survival/rules.pptx
@@ -74,16 +74,12 @@
   <p:notesSz cx="6858000" cy="9144000"/>
   <p:embeddedFontLst>
     <p:embeddedFont>
-      <p:font typeface="Jua" charset="1" panose="00000000000000000000"/>
+      <p:font typeface="무궁화 고딕" charset="1" panose="02020603020101020101"/>
       <p:regular r:id="rId70"/>
     </p:embeddedFont>
     <p:embeddedFont>
-      <p:font typeface="TDTD갬성명조" charset="1" panose="02000503000000000000"/>
+      <p:font typeface="무궁화 고딕 Bold" charset="1" panose="02020603020101020101"/>
       <p:regular r:id="rId71"/>
-    </p:embeddedFont>
-    <p:embeddedFont>
-      <p:font typeface="TDTD가온" charset="1" panose="02000503000000000000"/>
-      <p:regular r:id="rId72"/>
     </p:embeddedFont>
   </p:embeddedFontLst>
   <p:defaultTextStyle>
@@ -3201,8 +3197,8 @@
         </p:nvSpPr>
         <p:spPr>
           <a:xfrm rot="0">
-            <a:off x="1028700" y="3892867"/>
-            <a:ext cx="15555091" cy="2200275"/>
+            <a:off x="1028700" y="4178617"/>
+            <a:ext cx="15555091" cy="1914525"/>
           </a:xfrm>
           <a:prstGeom prst="rect">
             <a:avLst/>
@@ -3224,10 +3220,10 @@
                 <a:solidFill>
                   <a:srgbClr val="FFFAEF"/>
                 </a:solidFill>
-                <a:latin typeface="Jua"/>
-                <a:ea typeface="Jua"/>
-                <a:cs typeface="Jua"/>
-                <a:sym typeface="Jua"/>
+                <a:latin typeface="무궁화 고딕"/>
+                <a:ea typeface="무궁화 고딕"/>
+                <a:cs typeface="무궁화 고딕"/>
+                <a:sym typeface="무궁화 고딕"/>
               </a:rPr>
               <a:t>O/X 퀴즈</a:t>
             </a:r>
@@ -3242,8 +3238,8 @@
         </p:nvSpPr>
         <p:spPr>
           <a:xfrm rot="0">
-            <a:off x="15264803" y="9812655"/>
-            <a:ext cx="2637975" cy="474345"/>
+            <a:off x="14903856" y="9822180"/>
+            <a:ext cx="2998923" cy="464820"/>
           </a:xfrm>
           <a:prstGeom prst="rect">
             <a:avLst/>
@@ -3268,10 +3264,10 @@
                 <a:solidFill>
                   <a:srgbClr val="FFFFFF"/>
                 </a:solidFill>
-                <a:latin typeface="TDTD갬성명조"/>
-                <a:ea typeface="TDTD갬성명조"/>
-                <a:cs typeface="TDTD갬성명조"/>
-                <a:sym typeface="TDTD갬성명조"/>
+                <a:latin typeface="무궁화 고딕"/>
+                <a:ea typeface="무궁화 고딕"/>
+                <a:cs typeface="무궁화 고딕"/>
+                <a:sym typeface="무궁화 고딕"/>
               </a:rPr>
               <a:t>ⓒ 2026. Sunday Play</a:t>
             </a:r>
@@ -3318,8 +3314,8 @@
         </p:nvSpPr>
         <p:spPr>
           <a:xfrm rot="0">
-            <a:off x="3238925" y="3140295"/>
-            <a:ext cx="11810151" cy="4105275"/>
+            <a:off x="3238925" y="3426045"/>
+            <a:ext cx="11810151" cy="3819525"/>
           </a:xfrm>
           <a:prstGeom prst="rect">
             <a:avLst/>
@@ -3341,10 +3337,10 @@
                 <a:solidFill>
                   <a:srgbClr val="000000"/>
                 </a:solidFill>
-                <a:latin typeface="Jua"/>
-                <a:ea typeface="Jua"/>
-                <a:cs typeface="Jua"/>
-                <a:sym typeface="Jua"/>
+                <a:latin typeface="무궁화 고딕"/>
+                <a:ea typeface="무궁화 고딕"/>
+                <a:cs typeface="무궁화 고딕"/>
+                <a:sym typeface="무궁화 고딕"/>
               </a:rPr>
               <a:t>바나나는 나무에서 열린다</a:t>
             </a:r>
@@ -3441,8 +3437,8 @@
         </p:nvSpPr>
         <p:spPr>
           <a:xfrm rot="0">
-            <a:off x="3238925" y="1187670"/>
-            <a:ext cx="11810151" cy="7581900"/>
+            <a:off x="3238925" y="1902045"/>
+            <a:ext cx="11810151" cy="6867525"/>
           </a:xfrm>
           <a:prstGeom prst="rect">
             <a:avLst/>
@@ -3464,10 +3460,10 @@
                 <a:solidFill>
                   <a:srgbClr val="000000"/>
                 </a:solidFill>
-                <a:latin typeface="Jua"/>
-                <a:ea typeface="Jua"/>
-                <a:cs typeface="Jua"/>
-                <a:sym typeface="Jua"/>
+                <a:latin typeface="무궁화 고딕"/>
+                <a:ea typeface="무궁화 고딕"/>
+                <a:cs typeface="무궁화 고딕"/>
+                <a:sym typeface="무궁화 고딕"/>
               </a:rPr>
               <a:t>X</a:t>
             </a:r>
@@ -3483,10 +3479,10 @@
                 <a:solidFill>
                   <a:srgbClr val="000000"/>
                 </a:solidFill>
-                <a:latin typeface="Jua"/>
-                <a:ea typeface="Jua"/>
-                <a:cs typeface="Jua"/>
-                <a:sym typeface="Jua"/>
+                <a:latin typeface="무궁화 고딕"/>
+                <a:ea typeface="무궁화 고딕"/>
+                <a:cs typeface="무궁화 고딕"/>
+                <a:sym typeface="무궁화 고딕"/>
               </a:rPr>
               <a:t>(바나나는 풀)</a:t>
             </a:r>
@@ -3583,8 +3579,8 @@
         </p:nvSpPr>
         <p:spPr>
           <a:xfrm rot="0">
-            <a:off x="1619462" y="2943225"/>
-            <a:ext cx="15049075" cy="4105275"/>
+            <a:off x="1619462" y="3228975"/>
+            <a:ext cx="15049075" cy="3819525"/>
           </a:xfrm>
           <a:prstGeom prst="rect">
             <a:avLst/>
@@ -3606,10 +3602,10 @@
                 <a:solidFill>
                   <a:srgbClr val="000000"/>
                 </a:solidFill>
-                <a:latin typeface="Jua"/>
-                <a:ea typeface="Jua"/>
-                <a:cs typeface="Jua"/>
-                <a:sym typeface="Jua"/>
+                <a:latin typeface="무궁화 고딕"/>
+                <a:ea typeface="무궁화 고딕"/>
+                <a:cs typeface="무궁화 고딕"/>
+                <a:sym typeface="무궁화 고딕"/>
               </a:rPr>
               <a:t>세계에서 인구가 가장</a:t>
             </a:r>
@@ -3625,10 +3621,10 @@
                 <a:solidFill>
                   <a:srgbClr val="000000"/>
                 </a:solidFill>
-                <a:latin typeface="Jua"/>
-                <a:ea typeface="Jua"/>
-                <a:cs typeface="Jua"/>
-                <a:sym typeface="Jua"/>
+                <a:latin typeface="무궁화 고딕"/>
+                <a:ea typeface="무궁화 고딕"/>
+                <a:cs typeface="무궁화 고딕"/>
+                <a:sym typeface="무궁화 고딕"/>
               </a:rPr>
               <a:t>많은 나라는 중국이다</a:t>
             </a:r>
@@ -3725,8 +3721,8 @@
         </p:nvSpPr>
         <p:spPr>
           <a:xfrm rot="0">
-            <a:off x="3238925" y="1187670"/>
-            <a:ext cx="11810151" cy="7581900"/>
+            <a:off x="3238925" y="1902045"/>
+            <a:ext cx="11810151" cy="6867525"/>
           </a:xfrm>
           <a:prstGeom prst="rect">
             <a:avLst/>
@@ -3748,10 +3744,10 @@
                 <a:solidFill>
                   <a:srgbClr val="000000"/>
                 </a:solidFill>
-                <a:latin typeface="Jua"/>
-                <a:ea typeface="Jua"/>
-                <a:cs typeface="Jua"/>
-                <a:sym typeface="Jua"/>
+                <a:latin typeface="무궁화 고딕"/>
+                <a:ea typeface="무궁화 고딕"/>
+                <a:cs typeface="무궁화 고딕"/>
+                <a:sym typeface="무궁화 고딕"/>
               </a:rPr>
               <a:t>X</a:t>
             </a:r>
@@ -3767,10 +3763,10 @@
                 <a:solidFill>
                   <a:srgbClr val="000000"/>
                 </a:solidFill>
-                <a:latin typeface="Jua"/>
-                <a:ea typeface="Jua"/>
-                <a:cs typeface="Jua"/>
-                <a:sym typeface="Jua"/>
+                <a:latin typeface="무궁화 고딕"/>
+                <a:ea typeface="무궁화 고딕"/>
+                <a:cs typeface="무궁화 고딕"/>
+                <a:sym typeface="무궁화 고딕"/>
               </a:rPr>
               <a:t>(인도)</a:t>
             </a:r>
@@ -3867,8 +3863,8 @@
         </p:nvSpPr>
         <p:spPr>
           <a:xfrm rot="0">
-            <a:off x="3238925" y="4092795"/>
-            <a:ext cx="11810151" cy="2200275"/>
+            <a:off x="3238925" y="4378545"/>
+            <a:ext cx="11810151" cy="1914525"/>
           </a:xfrm>
           <a:prstGeom prst="rect">
             <a:avLst/>
@@ -3890,10 +3886,10 @@
                 <a:solidFill>
                   <a:srgbClr val="000000"/>
                 </a:solidFill>
-                <a:latin typeface="Jua"/>
-                <a:ea typeface="Jua"/>
-                <a:cs typeface="Jua"/>
-                <a:sym typeface="Jua"/>
+                <a:latin typeface="무궁화 고딕"/>
+                <a:ea typeface="무궁화 고딕"/>
+                <a:cs typeface="무궁화 고딕"/>
+                <a:sym typeface="무궁화 고딕"/>
               </a:rPr>
               <a:t>고래는 물고기이다</a:t>
             </a:r>
@@ -3990,8 +3986,8 @@
         </p:nvSpPr>
         <p:spPr>
           <a:xfrm rot="0">
-            <a:off x="3238925" y="1187670"/>
-            <a:ext cx="11810151" cy="7581900"/>
+            <a:off x="3238925" y="1902045"/>
+            <a:ext cx="11810151" cy="6867525"/>
           </a:xfrm>
           <a:prstGeom prst="rect">
             <a:avLst/>
@@ -4013,10 +4009,10 @@
                 <a:solidFill>
                   <a:srgbClr val="000000"/>
                 </a:solidFill>
-                <a:latin typeface="Jua"/>
-                <a:ea typeface="Jua"/>
-                <a:cs typeface="Jua"/>
-                <a:sym typeface="Jua"/>
+                <a:latin typeface="무궁화 고딕"/>
+                <a:ea typeface="무궁화 고딕"/>
+                <a:cs typeface="무궁화 고딕"/>
+                <a:sym typeface="무궁화 고딕"/>
               </a:rPr>
               <a:t>X</a:t>
             </a:r>
@@ -4032,10 +4028,10 @@
                 <a:solidFill>
                   <a:srgbClr val="000000"/>
                 </a:solidFill>
-                <a:latin typeface="Jua"/>
-                <a:ea typeface="Jua"/>
-                <a:cs typeface="Jua"/>
-                <a:sym typeface="Jua"/>
+                <a:latin typeface="무궁화 고딕"/>
+                <a:ea typeface="무궁화 고딕"/>
+                <a:cs typeface="무궁화 고딕"/>
+                <a:sym typeface="무궁화 고딕"/>
               </a:rPr>
               <a:t>(포유류)</a:t>
             </a:r>
@@ -4132,8 +4128,8 @@
         </p:nvSpPr>
         <p:spPr>
           <a:xfrm rot="0">
-            <a:off x="2133812" y="3895725"/>
-            <a:ext cx="14020375" cy="2200275"/>
+            <a:off x="2133812" y="4205287"/>
+            <a:ext cx="14020375" cy="1866900"/>
           </a:xfrm>
           <a:prstGeom prst="rect">
             <a:avLst/>
@@ -4147,18 +4143,18 @@
           <a:p>
             <a:pPr algn="ctr">
               <a:lnSpc>
-                <a:spcPts val="15000"/>
+                <a:spcPts val="14640"/>
               </a:lnSpc>
             </a:pPr>
             <a:r>
-              <a:rPr lang="en-US" sz="12500">
+              <a:rPr lang="en-US" sz="12200">
                 <a:solidFill>
                   <a:srgbClr val="000000"/>
                 </a:solidFill>
-                <a:latin typeface="Jua"/>
-                <a:ea typeface="Jua"/>
-                <a:cs typeface="Jua"/>
-                <a:sym typeface="Jua"/>
+                <a:latin typeface="무궁화 고딕"/>
+                <a:ea typeface="무궁화 고딕"/>
+                <a:cs typeface="무궁화 고딕"/>
+                <a:sym typeface="무궁화 고딕"/>
               </a:rPr>
               <a:t>문어의 심장은 3개이다</a:t>
             </a:r>
@@ -4255,8 +4251,8 @@
         </p:nvSpPr>
         <p:spPr>
           <a:xfrm rot="0">
-            <a:off x="3238925" y="2330670"/>
-            <a:ext cx="11810151" cy="5295900"/>
+            <a:off x="3238925" y="3045045"/>
+            <a:ext cx="11810151" cy="4581525"/>
           </a:xfrm>
           <a:prstGeom prst="rect">
             <a:avLst/>
@@ -4278,10 +4274,10 @@
                 <a:solidFill>
                   <a:srgbClr val="000000"/>
                 </a:solidFill>
-                <a:latin typeface="Jua"/>
-                <a:ea typeface="Jua"/>
-                <a:cs typeface="Jua"/>
-                <a:sym typeface="Jua"/>
+                <a:latin typeface="무궁화 고딕"/>
+                <a:ea typeface="무궁화 고딕"/>
+                <a:cs typeface="무궁화 고딕"/>
+                <a:sym typeface="무궁화 고딕"/>
               </a:rPr>
               <a:t>O</a:t>
             </a:r>
@@ -4378,8 +4374,8 @@
         </p:nvSpPr>
         <p:spPr>
           <a:xfrm rot="0">
-            <a:off x="3238925" y="3140295"/>
-            <a:ext cx="11810151" cy="4105275"/>
+            <a:off x="3238925" y="3426045"/>
+            <a:ext cx="11810151" cy="3819525"/>
           </a:xfrm>
           <a:prstGeom prst="rect">
             <a:avLst/>
@@ -4401,10 +4397,10 @@
                 <a:solidFill>
                   <a:srgbClr val="000000"/>
                 </a:solidFill>
-                <a:latin typeface="Jua"/>
-                <a:ea typeface="Jua"/>
-                <a:cs typeface="Jua"/>
-                <a:sym typeface="Jua"/>
+                <a:latin typeface="무궁화 고딕"/>
+                <a:ea typeface="무궁화 고딕"/>
+                <a:cs typeface="무궁화 고딕"/>
+                <a:sym typeface="무궁화 고딕"/>
               </a:rPr>
               <a:t>금붕어의 기억력은 3초이다</a:t>
             </a:r>
@@ -4501,8 +4497,8 @@
         </p:nvSpPr>
         <p:spPr>
           <a:xfrm rot="0">
-            <a:off x="3238925" y="1344833"/>
-            <a:ext cx="11810151" cy="7267575"/>
+            <a:off x="3238925" y="2125883"/>
+            <a:ext cx="11810151" cy="6419850"/>
           </a:xfrm>
           <a:prstGeom prst="rect">
             <a:avLst/>
@@ -4524,10 +4520,10 @@
                 <a:solidFill>
                   <a:srgbClr val="000000"/>
                 </a:solidFill>
-                <a:latin typeface="Jua"/>
-                <a:ea typeface="Jua"/>
-                <a:cs typeface="Jua"/>
-                <a:sym typeface="Jua"/>
+                <a:latin typeface="무궁화 고딕"/>
+                <a:ea typeface="무궁화 고딕"/>
+                <a:cs typeface="무궁화 고딕"/>
+                <a:sym typeface="무궁화 고딕"/>
               </a:rPr>
               <a:t>X</a:t>
             </a:r>
@@ -4535,18 +4531,18 @@
           <a:p>
             <a:pPr algn="ctr">
               <a:lnSpc>
-                <a:spcPts val="15599"/>
+                <a:spcPts val="14520"/>
               </a:lnSpc>
             </a:pPr>
             <a:r>
-              <a:rPr lang="en-US" sz="12999">
+              <a:rPr lang="en-US" sz="12100">
                 <a:solidFill>
                   <a:srgbClr val="000000"/>
                 </a:solidFill>
-                <a:latin typeface="Jua"/>
-                <a:ea typeface="Jua"/>
-                <a:cs typeface="Jua"/>
-                <a:sym typeface="Jua"/>
+                <a:latin typeface="무궁화 고딕"/>
+                <a:ea typeface="무궁화 고딕"/>
+                <a:cs typeface="무궁화 고딕"/>
+                <a:sym typeface="무궁화 고딕"/>
               </a:rPr>
               <a:t>(수개월 기억 가능)</a:t>
             </a:r>
@@ -4745,8 +4741,8 @@
         </p:nvSpPr>
         <p:spPr>
           <a:xfrm rot="0">
-            <a:off x="11392761" y="600705"/>
-            <a:ext cx="5362043" cy="1600200"/>
+            <a:off x="11392761" y="819780"/>
+            <a:ext cx="5362043" cy="1381125"/>
           </a:xfrm>
           <a:prstGeom prst="rect">
             <a:avLst/>
@@ -4768,10 +4764,10 @@
                 <a:solidFill>
                   <a:srgbClr val="FFFAEF"/>
                 </a:solidFill>
-                <a:latin typeface="Jua"/>
-                <a:ea typeface="Jua"/>
-                <a:cs typeface="Jua"/>
-                <a:sym typeface="Jua"/>
+                <a:latin typeface="무궁화 고딕"/>
+                <a:ea typeface="무궁화 고딕"/>
+                <a:cs typeface="무궁화 고딕"/>
+                <a:sym typeface="무궁화 고딕"/>
               </a:rPr>
               <a:t>규칙</a:t>
             </a:r>
@@ -4787,9 +4783,9 @@
         <p:grpSpPr>
           <a:xfrm rot="0">
             <a:off x="309172" y="535073"/>
-            <a:ext cx="12078314" cy="1779769"/>
+            <a:ext cx="12078314" cy="1701684"/>
             <a:chOff x="0" y="0"/>
-            <a:chExt cx="16104419" cy="2373026"/>
+            <a:chExt cx="16104419" cy="2268911"/>
           </a:xfrm>
         </p:grpSpPr>
         <p:sp>
@@ -4800,8 +4796,8 @@
           </p:nvSpPr>
           <p:spPr>
             <a:xfrm rot="0">
-              <a:off x="0" y="1380584"/>
-              <a:ext cx="16104419" cy="992442"/>
+              <a:off x="0" y="1388378"/>
+              <a:ext cx="16104419" cy="880533"/>
             </a:xfrm>
             <a:prstGeom prst="rect">
               <a:avLst/>
@@ -4815,30 +4811,30 @@
             <a:p>
               <a:pPr algn="l">
                 <a:lnSpc>
-                  <a:spcPts val="6273"/>
+                  <a:spcPts val="5599"/>
                 </a:lnSpc>
               </a:pPr>
               <a:r>
-                <a:rPr lang="en-US" sz="4480">
+                <a:rPr lang="en-US" sz="3999">
                   <a:solidFill>
                     <a:srgbClr val="FFFAEF"/>
                   </a:solidFill>
-                  <a:latin typeface="TDTD가온"/>
-                  <a:ea typeface="TDTD가온"/>
-                  <a:cs typeface="TDTD가온"/>
-                  <a:sym typeface="TDTD가온"/>
+                  <a:latin typeface="무궁화 고딕"/>
+                  <a:ea typeface="무궁화 고딕"/>
+                  <a:cs typeface="무궁화 고딕"/>
+                  <a:sym typeface="무궁화 고딕"/>
                 </a:rPr>
                 <a:t>O / X 구역을 나누고, 참가자 전원 중앙에</a:t>
               </a:r>
               <a:r>
-                <a:rPr lang="en-US" sz="4480">
+                <a:rPr lang="en-US" sz="3999">
                   <a:solidFill>
                     <a:srgbClr val="FFFAEF"/>
                   </a:solidFill>
-                  <a:latin typeface="TDTD가온"/>
-                  <a:ea typeface="TDTD가온"/>
-                  <a:cs typeface="TDTD가온"/>
-                  <a:sym typeface="TDTD가온"/>
+                  <a:latin typeface="무궁화 고딕"/>
+                  <a:ea typeface="무궁화 고딕"/>
+                  <a:cs typeface="무궁화 고딕"/>
+                  <a:sym typeface="무궁화 고딕"/>
                 </a:rPr>
                 <a:t> 모입니다.</a:t>
               </a:r>
@@ -4853,8 +4849,8 @@
           </p:nvSpPr>
           <p:spPr>
             <a:xfrm rot="0">
-              <a:off x="0" y="-171450"/>
-              <a:ext cx="9574913" cy="1169217"/>
+              <a:off x="0" y="-66675"/>
+              <a:ext cx="9574913" cy="1062712"/>
             </a:xfrm>
             <a:prstGeom prst="rect">
               <a:avLst/>
@@ -4876,10 +4872,10 @@
                   <a:solidFill>
                     <a:srgbClr val="FFFAEF"/>
                   </a:solidFill>
-                  <a:latin typeface="Jua"/>
-                  <a:ea typeface="Jua"/>
-                  <a:cs typeface="Jua"/>
-                  <a:sym typeface="Jua"/>
+                  <a:latin typeface="무궁화 고딕 Bold"/>
+                  <a:ea typeface="무궁화 고딕 Bold"/>
+                  <a:cs typeface="무궁화 고딕 Bold"/>
+                  <a:sym typeface="무궁화 고딕 Bold"/>
                 </a:rPr>
                 <a:t>STEP 1.</a:t>
               </a:r>
@@ -4895,10 +4891,10 @@
         </p:nvGrpSpPr>
         <p:grpSpPr>
           <a:xfrm rot="0">
-            <a:off x="12507852" y="7984396"/>
-            <a:ext cx="5385378" cy="1778769"/>
+            <a:off x="12507852" y="8200435"/>
+            <a:ext cx="5385378" cy="1697863"/>
             <a:chOff x="0" y="0"/>
-            <a:chExt cx="7180505" cy="2371692"/>
+            <a:chExt cx="7180505" cy="2263817"/>
           </a:xfrm>
         </p:grpSpPr>
         <p:sp>
@@ -4909,8 +4905,8 @@
           </p:nvSpPr>
           <p:spPr>
             <a:xfrm rot="0">
-              <a:off x="0" y="1377534"/>
-              <a:ext cx="7070728" cy="994158"/>
+              <a:off x="0" y="1383283"/>
+              <a:ext cx="7070728" cy="880533"/>
             </a:xfrm>
             <a:prstGeom prst="rect">
               <a:avLst/>
@@ -4924,18 +4920,18 @@
             <a:p>
               <a:pPr algn="l">
                 <a:lnSpc>
-                  <a:spcPts val="6284"/>
+                  <a:spcPts val="5599"/>
                 </a:lnSpc>
               </a:pPr>
               <a:r>
-                <a:rPr lang="en-US" sz="4489">
+                <a:rPr lang="en-US" sz="3999">
                   <a:solidFill>
                     <a:srgbClr val="FFFAEF"/>
                   </a:solidFill>
-                  <a:latin typeface="TDTD가온"/>
-                  <a:ea typeface="TDTD가온"/>
-                  <a:cs typeface="TDTD가온"/>
-                  <a:sym typeface="TDTD가온"/>
+                  <a:latin typeface="무궁화 고딕"/>
+                  <a:ea typeface="무궁화 고딕"/>
+                  <a:cs typeface="무궁화 고딕"/>
+                  <a:sym typeface="무궁화 고딕"/>
                 </a:rPr>
                 <a:t>최후의 1인이 우승!</a:t>
               </a:r>
@@ -4950,8 +4946,8 @@
           </p:nvSpPr>
           <p:spPr>
             <a:xfrm rot="0">
-              <a:off x="0" y="-171450"/>
-              <a:ext cx="7180505" cy="1171105"/>
+              <a:off x="0" y="-57150"/>
+              <a:ext cx="7180505" cy="1053029"/>
             </a:xfrm>
             <a:prstGeom prst="rect">
               <a:avLst/>
@@ -4973,10 +4969,10 @@
                   <a:solidFill>
                     <a:srgbClr val="FFFAEF"/>
                   </a:solidFill>
-                  <a:latin typeface="Jua"/>
-                  <a:ea typeface="Jua"/>
-                  <a:cs typeface="Jua"/>
-                  <a:sym typeface="Jua"/>
+                  <a:latin typeface="무궁화 고딕 Bold"/>
+                  <a:ea typeface="무궁화 고딕 Bold"/>
+                  <a:cs typeface="무궁화 고딕 Bold"/>
+                  <a:sym typeface="무궁화 고딕 Bold"/>
                 </a:rPr>
                 <a:t>STEP 3.</a:t>
               </a:r>
@@ -4992,10 +4988,10 @@
         </p:nvGrpSpPr>
         <p:grpSpPr>
           <a:xfrm rot="0">
-            <a:off x="4115632" y="3864595"/>
-            <a:ext cx="10056735" cy="2570047"/>
+            <a:off x="4115632" y="4017465"/>
+            <a:ext cx="10056735" cy="2402261"/>
             <a:chOff x="0" y="0"/>
-            <a:chExt cx="13408980" cy="3426730"/>
+            <a:chExt cx="13408980" cy="3203015"/>
           </a:xfrm>
         </p:grpSpPr>
         <p:sp>
@@ -5006,8 +5002,8 @@
           </p:nvSpPr>
           <p:spPr>
             <a:xfrm rot="0">
-              <a:off x="0" y="1375218"/>
-              <a:ext cx="13408980" cy="2051512"/>
+              <a:off x="0" y="1382681"/>
+              <a:ext cx="13408980" cy="1820333"/>
             </a:xfrm>
             <a:prstGeom prst="rect">
               <a:avLst/>
@@ -5021,18 +5017,18 @@
             <a:p>
               <a:pPr algn="l">
                 <a:lnSpc>
-                  <a:spcPts val="6275"/>
+                  <a:spcPts val="5599"/>
                 </a:lnSpc>
               </a:pPr>
               <a:r>
-                <a:rPr lang="en-US" sz="4482">
+                <a:rPr lang="en-US" sz="3999">
                   <a:solidFill>
                     <a:srgbClr val="FFFAEF"/>
                   </a:solidFill>
-                  <a:latin typeface="TDTD가온"/>
-                  <a:ea typeface="TDTD가온"/>
-                  <a:cs typeface="TDTD가온"/>
-                  <a:sym typeface="TDTD가온"/>
+                  <a:latin typeface="무궁화 고딕"/>
+                  <a:ea typeface="무궁화 고딕"/>
+                  <a:cs typeface="무궁화 고딕"/>
+                  <a:sym typeface="무궁화 고딕"/>
                 </a:rPr>
                 <a:t>문제가 나오면 10초 안에 O 또는 X 구역으로 이동!                                 </a:t>
               </a:r>
@@ -5040,18 +5036,18 @@
             <a:p>
               <a:pPr algn="l">
                 <a:lnSpc>
-                  <a:spcPts val="6275"/>
+                  <a:spcPts val="5599"/>
                 </a:lnSpc>
               </a:pPr>
               <a:r>
-                <a:rPr lang="en-US" sz="4482">
+                <a:rPr lang="en-US" sz="3999">
                   <a:solidFill>
                     <a:srgbClr val="FFFAEF"/>
                   </a:solidFill>
-                  <a:latin typeface="TDTD가온"/>
-                  <a:ea typeface="TDTD가온"/>
-                  <a:cs typeface="TDTD가온"/>
-                  <a:sym typeface="TDTD가온"/>
+                  <a:latin typeface="무궁화 고딕"/>
+                  <a:ea typeface="무궁화 고딕"/>
+                  <a:cs typeface="무궁화 고딕"/>
+                  <a:sym typeface="무궁화 고딕"/>
                 </a:rPr>
                 <a:t>틀리면 탈락!</a:t>
               </a:r>
@@ -5066,8 +5062,8 @@
           </p:nvSpPr>
           <p:spPr>
             <a:xfrm rot="0">
-              <a:off x="0" y="-171450"/>
-              <a:ext cx="6898637" cy="1169523"/>
+              <a:off x="0" y="-57150"/>
+              <a:ext cx="6898637" cy="1053161"/>
             </a:xfrm>
             <a:prstGeom prst="rect">
               <a:avLst/>
@@ -5089,10 +5085,10 @@
                   <a:solidFill>
                     <a:srgbClr val="FFFAEF"/>
                   </a:solidFill>
-                  <a:latin typeface="Jua"/>
-                  <a:ea typeface="Jua"/>
-                  <a:cs typeface="Jua"/>
-                  <a:sym typeface="Jua"/>
+                  <a:latin typeface="무궁화 고딕 Bold"/>
+                  <a:ea typeface="무궁화 고딕 Bold"/>
+                  <a:cs typeface="무궁화 고딕 Bold"/>
+                  <a:sym typeface="무궁화 고딕 Bold"/>
                 </a:rPr>
                 <a:t>STEP 2.</a:t>
               </a:r>
@@ -5140,8 +5136,8 @@
         </p:nvSpPr>
         <p:spPr>
           <a:xfrm rot="0">
-            <a:off x="3238925" y="4092795"/>
-            <a:ext cx="11810151" cy="2200275"/>
+            <a:off x="3238925" y="4378545"/>
+            <a:ext cx="11810151" cy="1914525"/>
           </a:xfrm>
           <a:prstGeom prst="rect">
             <a:avLst/>
@@ -5163,10 +5159,10 @@
                 <a:solidFill>
                   <a:srgbClr val="000000"/>
                 </a:solidFill>
-                <a:latin typeface="Jua"/>
-                <a:ea typeface="Jua"/>
-                <a:cs typeface="Jua"/>
-                <a:sym typeface="Jua"/>
+                <a:latin typeface="무궁화 고딕"/>
+                <a:ea typeface="무궁화 고딕"/>
+                <a:cs typeface="무궁화 고딕"/>
+                <a:sym typeface="무궁화 고딕"/>
               </a:rPr>
               <a:t>감자는 뿌리이다</a:t>
             </a:r>
@@ -5263,8 +5259,8 @@
         </p:nvSpPr>
         <p:spPr>
           <a:xfrm rot="0">
-            <a:off x="3238925" y="1187670"/>
-            <a:ext cx="11810151" cy="7581900"/>
+            <a:off x="3238925" y="1902045"/>
+            <a:ext cx="11810151" cy="6867525"/>
           </a:xfrm>
           <a:prstGeom prst="rect">
             <a:avLst/>
@@ -5286,10 +5282,10 @@
                 <a:solidFill>
                   <a:srgbClr val="000000"/>
                 </a:solidFill>
-                <a:latin typeface="Jua"/>
-                <a:ea typeface="Jua"/>
-                <a:cs typeface="Jua"/>
-                <a:sym typeface="Jua"/>
+                <a:latin typeface="무궁화 고딕"/>
+                <a:ea typeface="무궁화 고딕"/>
+                <a:cs typeface="무궁화 고딕"/>
+                <a:sym typeface="무궁화 고딕"/>
               </a:rPr>
               <a:t>X</a:t>
             </a:r>
@@ -5305,10 +5301,10 @@
                 <a:solidFill>
                   <a:srgbClr val="000000"/>
                 </a:solidFill>
-                <a:latin typeface="Jua"/>
-                <a:ea typeface="Jua"/>
-                <a:cs typeface="Jua"/>
-                <a:sym typeface="Jua"/>
+                <a:latin typeface="무궁화 고딕"/>
+                <a:ea typeface="무궁화 고딕"/>
+                <a:cs typeface="무궁화 고딕"/>
+                <a:sym typeface="무궁화 고딕"/>
               </a:rPr>
               <a:t>(줄기)</a:t>
             </a:r>
@@ -5405,8 +5401,8 @@
         </p:nvSpPr>
         <p:spPr>
           <a:xfrm rot="0">
-            <a:off x="3238925" y="3140295"/>
-            <a:ext cx="11810151" cy="4105275"/>
+            <a:off x="3238925" y="3426045"/>
+            <a:ext cx="11810151" cy="3819525"/>
           </a:xfrm>
           <a:prstGeom prst="rect">
             <a:avLst/>
@@ -5428,10 +5424,10 @@
                 <a:solidFill>
                   <a:srgbClr val="000000"/>
                 </a:solidFill>
-                <a:latin typeface="Jua"/>
-                <a:ea typeface="Jua"/>
-                <a:cs typeface="Jua"/>
-                <a:sym typeface="Jua"/>
+                <a:latin typeface="무궁화 고딕"/>
+                <a:ea typeface="무궁화 고딕"/>
+                <a:cs typeface="무궁화 고딕"/>
+                <a:sym typeface="무궁화 고딕"/>
               </a:rPr>
               <a:t>라면은 한국에서</a:t>
             </a:r>
@@ -5447,10 +5443,10 @@
                 <a:solidFill>
                   <a:srgbClr val="000000"/>
                 </a:solidFill>
-                <a:latin typeface="Jua"/>
-                <a:ea typeface="Jua"/>
-                <a:cs typeface="Jua"/>
-                <a:sym typeface="Jua"/>
+                <a:latin typeface="무궁화 고딕"/>
+                <a:ea typeface="무궁화 고딕"/>
+                <a:cs typeface="무궁화 고딕"/>
+                <a:sym typeface="무궁화 고딕"/>
               </a:rPr>
               <a:t>처음 만들어졌다</a:t>
             </a:r>
@@ -5547,8 +5543,8 @@
         </p:nvSpPr>
         <p:spPr>
           <a:xfrm rot="0">
-            <a:off x="3238925" y="1187670"/>
-            <a:ext cx="11810151" cy="7581900"/>
+            <a:off x="3238925" y="1902045"/>
+            <a:ext cx="11810151" cy="6867525"/>
           </a:xfrm>
           <a:prstGeom prst="rect">
             <a:avLst/>
@@ -5570,10 +5566,10 @@
                 <a:solidFill>
                   <a:srgbClr val="000000"/>
                 </a:solidFill>
-                <a:latin typeface="Jua"/>
-                <a:ea typeface="Jua"/>
-                <a:cs typeface="Jua"/>
-                <a:sym typeface="Jua"/>
+                <a:latin typeface="무궁화 고딕"/>
+                <a:ea typeface="무궁화 고딕"/>
+                <a:cs typeface="무궁화 고딕"/>
+                <a:sym typeface="무궁화 고딕"/>
               </a:rPr>
               <a:t>X</a:t>
             </a:r>
@@ -5589,10 +5585,10 @@
                 <a:solidFill>
                   <a:srgbClr val="000000"/>
                 </a:solidFill>
-                <a:latin typeface="Jua"/>
-                <a:ea typeface="Jua"/>
-                <a:cs typeface="Jua"/>
-                <a:sym typeface="Jua"/>
+                <a:latin typeface="무궁화 고딕"/>
+                <a:ea typeface="무궁화 고딕"/>
+                <a:cs typeface="무궁화 고딕"/>
+                <a:sym typeface="무궁화 고딕"/>
               </a:rPr>
               <a:t>(일본)</a:t>
             </a:r>
@@ -5689,8 +5685,8 @@
         </p:nvSpPr>
         <p:spPr>
           <a:xfrm rot="0">
-            <a:off x="3238925" y="3140295"/>
-            <a:ext cx="11810151" cy="4105275"/>
+            <a:off x="3238925" y="3426045"/>
+            <a:ext cx="11810151" cy="3819525"/>
           </a:xfrm>
           <a:prstGeom prst="rect">
             <a:avLst/>
@@ -5712,10 +5708,10 @@
                 <a:solidFill>
                   <a:srgbClr val="000000"/>
                 </a:solidFill>
-                <a:latin typeface="Jua"/>
-                <a:ea typeface="Jua"/>
-                <a:cs typeface="Jua"/>
-                <a:sym typeface="Jua"/>
+                <a:latin typeface="무궁화 고딕"/>
+                <a:ea typeface="무궁화 고딕"/>
+                <a:cs typeface="무궁화 고딕"/>
+                <a:sym typeface="무궁화 고딕"/>
               </a:rPr>
               <a:t>하루에 머리카락은 약 100개씩 빠진다</a:t>
             </a:r>
@@ -5812,8 +5808,8 @@
         </p:nvSpPr>
         <p:spPr>
           <a:xfrm rot="0">
-            <a:off x="3238925" y="2330670"/>
-            <a:ext cx="11810151" cy="5295900"/>
+            <a:off x="3238925" y="3045045"/>
+            <a:ext cx="11810151" cy="4581525"/>
           </a:xfrm>
           <a:prstGeom prst="rect">
             <a:avLst/>
@@ -5835,10 +5831,10 @@
                 <a:solidFill>
                   <a:srgbClr val="000000"/>
                 </a:solidFill>
-                <a:latin typeface="Jua"/>
-                <a:ea typeface="Jua"/>
-                <a:cs typeface="Jua"/>
-                <a:sym typeface="Jua"/>
+                <a:latin typeface="무궁화 고딕"/>
+                <a:ea typeface="무궁화 고딕"/>
+                <a:cs typeface="무궁화 고딕"/>
+                <a:sym typeface="무궁화 고딕"/>
               </a:rPr>
               <a:t>O</a:t>
             </a:r>
@@ -5935,8 +5931,8 @@
         </p:nvSpPr>
         <p:spPr>
           <a:xfrm rot="0">
-            <a:off x="3238925" y="3140295"/>
-            <a:ext cx="11810151" cy="4105275"/>
+            <a:off x="3238925" y="3426045"/>
+            <a:ext cx="11810151" cy="3819525"/>
           </a:xfrm>
           <a:prstGeom prst="rect">
             <a:avLst/>
@@ -5958,10 +5954,10 @@
                 <a:solidFill>
                   <a:srgbClr val="000000"/>
                 </a:solidFill>
-                <a:latin typeface="Jua"/>
-                <a:ea typeface="Jua"/>
-                <a:cs typeface="Jua"/>
-                <a:sym typeface="Jua"/>
+                <a:latin typeface="무궁화 고딕"/>
+                <a:ea typeface="무궁화 고딕"/>
+                <a:cs typeface="무궁화 고딕"/>
+                <a:sym typeface="무궁화 고딕"/>
               </a:rPr>
               <a:t>에베레스트는 매년 높아지고 있다</a:t>
             </a:r>
@@ -6058,8 +6054,8 @@
         </p:nvSpPr>
         <p:spPr>
           <a:xfrm rot="0">
-            <a:off x="3238925" y="1263870"/>
-            <a:ext cx="11810151" cy="7429500"/>
+            <a:off x="3238925" y="1978245"/>
+            <a:ext cx="11810151" cy="6715125"/>
           </a:xfrm>
           <a:prstGeom prst="rect">
             <a:avLst/>
@@ -6081,10 +6077,10 @@
                 <a:solidFill>
                   <a:srgbClr val="000000"/>
                 </a:solidFill>
-                <a:latin typeface="Jua"/>
-                <a:ea typeface="Jua"/>
-                <a:cs typeface="Jua"/>
-                <a:sym typeface="Jua"/>
+                <a:latin typeface="무궁화 고딕"/>
+                <a:ea typeface="무궁화 고딕"/>
+                <a:cs typeface="무궁화 고딕"/>
+                <a:sym typeface="무궁화 고딕"/>
               </a:rPr>
               <a:t>O</a:t>
             </a:r>
@@ -6100,10 +6096,10 @@
                 <a:solidFill>
                   <a:srgbClr val="000000"/>
                 </a:solidFill>
-                <a:latin typeface="Jua"/>
-                <a:ea typeface="Jua"/>
-                <a:cs typeface="Jua"/>
-                <a:sym typeface="Jua"/>
+                <a:latin typeface="무궁화 고딕"/>
+                <a:ea typeface="무궁화 고딕"/>
+                <a:cs typeface="무궁화 고딕"/>
+                <a:sym typeface="무궁화 고딕"/>
               </a:rPr>
               <a:t>(2~4mm씩)</a:t>
             </a:r>
@@ -6200,8 +6196,8 @@
         </p:nvSpPr>
         <p:spPr>
           <a:xfrm rot="0">
-            <a:off x="3238925" y="4092795"/>
-            <a:ext cx="11810151" cy="2200275"/>
+            <a:off x="3238925" y="4378545"/>
+            <a:ext cx="11810151" cy="1914525"/>
           </a:xfrm>
           <a:prstGeom prst="rect">
             <a:avLst/>
@@ -6223,10 +6219,10 @@
                 <a:solidFill>
                   <a:srgbClr val="000000"/>
                 </a:solidFill>
-                <a:latin typeface="Jua"/>
-                <a:ea typeface="Jua"/>
-                <a:cs typeface="Jua"/>
-                <a:sym typeface="Jua"/>
+                <a:latin typeface="무궁화 고딕"/>
+                <a:ea typeface="무궁화 고딕"/>
+                <a:cs typeface="무궁화 고딕"/>
+                <a:sym typeface="무궁화 고딕"/>
               </a:rPr>
               <a:t>호주는 섬이다</a:t>
             </a:r>
@@ -6323,8 +6319,8 @@
         </p:nvSpPr>
         <p:spPr>
           <a:xfrm rot="0">
-            <a:off x="3238925" y="1263870"/>
-            <a:ext cx="11810151" cy="7429500"/>
+            <a:off x="3238925" y="1978245"/>
+            <a:ext cx="11810151" cy="6715125"/>
           </a:xfrm>
           <a:prstGeom prst="rect">
             <a:avLst/>
@@ -6346,10 +6342,10 @@
                 <a:solidFill>
                   <a:srgbClr val="000000"/>
                 </a:solidFill>
-                <a:latin typeface="Jua"/>
-                <a:ea typeface="Jua"/>
-                <a:cs typeface="Jua"/>
-                <a:sym typeface="Jua"/>
+                <a:latin typeface="무궁화 고딕"/>
+                <a:ea typeface="무궁화 고딕"/>
+                <a:cs typeface="무궁화 고딕"/>
+                <a:sym typeface="무궁화 고딕"/>
               </a:rPr>
               <a:t>X</a:t>
             </a:r>
@@ -6365,10 +6361,10 @@
                 <a:solidFill>
                   <a:srgbClr val="000000"/>
                 </a:solidFill>
-                <a:latin typeface="Jua"/>
-                <a:ea typeface="Jua"/>
-                <a:cs typeface="Jua"/>
-                <a:sym typeface="Jua"/>
+                <a:latin typeface="무궁화 고딕"/>
+                <a:ea typeface="무궁화 고딕"/>
+                <a:cs typeface="무궁화 고딕"/>
+                <a:sym typeface="무궁화 고딕"/>
               </a:rPr>
               <a:t>(대륙)</a:t>
             </a:r>
@@ -6515,8 +6511,8 @@
         </p:nvSpPr>
         <p:spPr>
           <a:xfrm rot="0">
-            <a:off x="1028700" y="3892867"/>
-            <a:ext cx="15555091" cy="2200275"/>
+            <a:off x="1028700" y="4178617"/>
+            <a:ext cx="15555091" cy="1914525"/>
           </a:xfrm>
           <a:prstGeom prst="rect">
             <a:avLst/>
@@ -6538,10 +6534,10 @@
                 <a:solidFill>
                   <a:srgbClr val="FFFAEF"/>
                 </a:solidFill>
-                <a:latin typeface="Jua"/>
-                <a:ea typeface="Jua"/>
-                <a:cs typeface="Jua"/>
-                <a:sym typeface="Jua"/>
+                <a:latin typeface="무궁화 고딕"/>
+                <a:ea typeface="무궁화 고딕"/>
+                <a:cs typeface="무궁화 고딕"/>
+                <a:sym typeface="무궁화 고딕"/>
               </a:rPr>
               <a:t>O/X 퀴즈</a:t>
             </a:r>
@@ -6556,8 +6552,8 @@
         </p:nvSpPr>
         <p:spPr>
           <a:xfrm rot="0">
-            <a:off x="15264803" y="9812655"/>
-            <a:ext cx="2637975" cy="474345"/>
+            <a:off x="14903856" y="9822180"/>
+            <a:ext cx="2998923" cy="464820"/>
           </a:xfrm>
           <a:prstGeom prst="rect">
             <a:avLst/>
@@ -6582,10 +6578,10 @@
                 <a:solidFill>
                   <a:srgbClr val="FFFFFF"/>
                 </a:solidFill>
-                <a:latin typeface="TDTD갬성명조"/>
-                <a:ea typeface="TDTD갬성명조"/>
-                <a:cs typeface="TDTD갬성명조"/>
-                <a:sym typeface="TDTD갬성명조"/>
+                <a:latin typeface="무궁화 고딕"/>
+                <a:ea typeface="무궁화 고딕"/>
+                <a:cs typeface="무궁화 고딕"/>
+                <a:sym typeface="무궁화 고딕"/>
               </a:rPr>
               <a:t>ⓒ 2026. Sunday Play</a:t>
             </a:r>
@@ -6632,8 +6628,8 @@
         </p:nvSpPr>
         <p:spPr>
           <a:xfrm rot="0">
-            <a:off x="2007300" y="2943225"/>
-            <a:ext cx="14273399" cy="4105275"/>
+            <a:off x="2007300" y="3343275"/>
+            <a:ext cx="14273399" cy="3590925"/>
           </a:xfrm>
           <a:prstGeom prst="rect">
             <a:avLst/>
@@ -6647,18 +6643,18 @@
           <a:p>
             <a:pPr algn="ctr">
               <a:lnSpc>
-                <a:spcPts val="15000"/>
+                <a:spcPts val="14160"/>
               </a:lnSpc>
             </a:pPr>
             <a:r>
-              <a:rPr lang="en-US" sz="12500">
+              <a:rPr lang="en-US" sz="11800">
                 <a:solidFill>
                   <a:srgbClr val="000000"/>
                 </a:solidFill>
-                <a:latin typeface="Jua"/>
-                <a:ea typeface="Jua"/>
-                <a:cs typeface="Jua"/>
-                <a:sym typeface="Jua"/>
+                <a:latin typeface="무궁화 고딕"/>
+                <a:ea typeface="무궁화 고딕"/>
+                <a:cs typeface="무궁화 고딕"/>
+                <a:sym typeface="무궁화 고딕"/>
               </a:rPr>
               <a:t>러시아는 아시아와 유럽 두 대륙에 걸쳐 있다</a:t>
             </a:r>
@@ -6755,8 +6751,8 @@
         </p:nvSpPr>
         <p:spPr>
           <a:xfrm rot="0">
-            <a:off x="3238925" y="2330670"/>
-            <a:ext cx="11810151" cy="5295900"/>
+            <a:off x="3238925" y="3045045"/>
+            <a:ext cx="11810151" cy="4581525"/>
           </a:xfrm>
           <a:prstGeom prst="rect">
             <a:avLst/>
@@ -6778,10 +6774,10 @@
                 <a:solidFill>
                   <a:srgbClr val="000000"/>
                 </a:solidFill>
-                <a:latin typeface="Jua"/>
-                <a:ea typeface="Jua"/>
-                <a:cs typeface="Jua"/>
-                <a:sym typeface="Jua"/>
+                <a:latin typeface="무궁화 고딕"/>
+                <a:ea typeface="무궁화 고딕"/>
+                <a:cs typeface="무궁화 고딕"/>
+                <a:sym typeface="무궁화 고딕"/>
               </a:rPr>
               <a:t>O</a:t>
             </a:r>
@@ -6878,8 +6874,8 @@
         </p:nvSpPr>
         <p:spPr>
           <a:xfrm rot="0">
-            <a:off x="2707530" y="2943225"/>
-            <a:ext cx="12872940" cy="4105275"/>
+            <a:off x="2707530" y="3343275"/>
+            <a:ext cx="12872940" cy="3590925"/>
           </a:xfrm>
           <a:prstGeom prst="rect">
             <a:avLst/>
@@ -6893,18 +6889,18 @@
           <a:p>
             <a:pPr algn="ctr">
               <a:lnSpc>
-                <a:spcPts val="15000"/>
+                <a:spcPts val="14160"/>
               </a:lnSpc>
             </a:pPr>
             <a:r>
-              <a:rPr lang="en-US" sz="12500">
+              <a:rPr lang="en-US" sz="11800">
                 <a:solidFill>
                   <a:srgbClr val="000000"/>
                 </a:solidFill>
-                <a:latin typeface="Jua"/>
-                <a:ea typeface="Jua"/>
-                <a:cs typeface="Jua"/>
-                <a:sym typeface="Jua"/>
+                <a:latin typeface="무궁화 고딕"/>
+                <a:ea typeface="무궁화 고딕"/>
+                <a:cs typeface="무궁화 고딕"/>
+                <a:sym typeface="무궁화 고딕"/>
               </a:rPr>
               <a:t>자유의 여신상은</a:t>
             </a:r>
@@ -6912,18 +6908,18 @@
           <a:p>
             <a:pPr algn="ctr">
               <a:lnSpc>
-                <a:spcPts val="15000"/>
+                <a:spcPts val="14160"/>
               </a:lnSpc>
             </a:pPr>
             <a:r>
-              <a:rPr lang="en-US" sz="12500">
+              <a:rPr lang="en-US" sz="11800">
                 <a:solidFill>
                   <a:srgbClr val="000000"/>
                 </a:solidFill>
-                <a:latin typeface="Jua"/>
-                <a:ea typeface="Jua"/>
-                <a:cs typeface="Jua"/>
-                <a:sym typeface="Jua"/>
+                <a:latin typeface="무궁화 고딕"/>
+                <a:ea typeface="무궁화 고딕"/>
+                <a:cs typeface="무궁화 고딕"/>
+                <a:sym typeface="무궁화 고딕"/>
               </a:rPr>
               <a:t>미국이 직접 만들었다</a:t>
             </a:r>
@@ -7020,8 +7016,8 @@
         </p:nvSpPr>
         <p:spPr>
           <a:xfrm rot="0">
-            <a:off x="3238925" y="1263870"/>
-            <a:ext cx="11810151" cy="7429500"/>
+            <a:off x="3238925" y="1978245"/>
+            <a:ext cx="11810151" cy="6715125"/>
           </a:xfrm>
           <a:prstGeom prst="rect">
             <a:avLst/>
@@ -7043,10 +7039,10 @@
                 <a:solidFill>
                   <a:srgbClr val="000000"/>
                 </a:solidFill>
-                <a:latin typeface="Jua"/>
-                <a:ea typeface="Jua"/>
-                <a:cs typeface="Jua"/>
-                <a:sym typeface="Jua"/>
+                <a:latin typeface="무궁화 고딕"/>
+                <a:ea typeface="무궁화 고딕"/>
+                <a:cs typeface="무궁화 고딕"/>
+                <a:sym typeface="무궁화 고딕"/>
               </a:rPr>
               <a:t>X</a:t>
             </a:r>
@@ -7062,10 +7058,10 @@
                 <a:solidFill>
                   <a:srgbClr val="000000"/>
                 </a:solidFill>
-                <a:latin typeface="Jua"/>
-                <a:ea typeface="Jua"/>
-                <a:cs typeface="Jua"/>
-                <a:sym typeface="Jua"/>
+                <a:latin typeface="무궁화 고딕"/>
+                <a:ea typeface="무궁화 고딕"/>
+                <a:cs typeface="무궁화 고딕"/>
+                <a:sym typeface="무궁화 고딕"/>
               </a:rPr>
               <a:t>(프랑스가 선물)</a:t>
             </a:r>
@@ -7162,8 +7158,8 @@
         </p:nvSpPr>
         <p:spPr>
           <a:xfrm rot="0">
-            <a:off x="3238925" y="4092795"/>
-            <a:ext cx="11810151" cy="2200275"/>
+            <a:off x="3238925" y="4378545"/>
+            <a:ext cx="11810151" cy="1914525"/>
           </a:xfrm>
           <a:prstGeom prst="rect">
             <a:avLst/>
@@ -7185,10 +7181,10 @@
                 <a:solidFill>
                   <a:srgbClr val="000000"/>
                 </a:solidFill>
-                <a:latin typeface="Jua"/>
-                <a:ea typeface="Jua"/>
-                <a:cs typeface="Jua"/>
-                <a:sym typeface="Jua"/>
+                <a:latin typeface="무궁화 고딕"/>
+                <a:ea typeface="무궁화 고딕"/>
+                <a:cs typeface="무궁화 고딕"/>
+                <a:sym typeface="무궁화 고딕"/>
               </a:rPr>
               <a:t>하품은 전염된다</a:t>
             </a:r>
@@ -7285,8 +7281,8 @@
         </p:nvSpPr>
         <p:spPr>
           <a:xfrm rot="0">
-            <a:off x="3238925" y="2330670"/>
-            <a:ext cx="11810151" cy="5295900"/>
+            <a:off x="3238925" y="3045045"/>
+            <a:ext cx="11810151" cy="4581525"/>
           </a:xfrm>
           <a:prstGeom prst="rect">
             <a:avLst/>
@@ -7308,10 +7304,10 @@
                 <a:solidFill>
                   <a:srgbClr val="000000"/>
                 </a:solidFill>
-                <a:latin typeface="Jua"/>
-                <a:ea typeface="Jua"/>
-                <a:cs typeface="Jua"/>
-                <a:sym typeface="Jua"/>
+                <a:latin typeface="무궁화 고딕"/>
+                <a:ea typeface="무궁화 고딕"/>
+                <a:cs typeface="무궁화 고딕"/>
+                <a:sym typeface="무궁화 고딕"/>
               </a:rPr>
               <a:t>O</a:t>
             </a:r>
@@ -7408,8 +7404,8 @@
         </p:nvSpPr>
         <p:spPr>
           <a:xfrm rot="0">
-            <a:off x="3238925" y="3140295"/>
-            <a:ext cx="11810151" cy="4105275"/>
+            <a:off x="3238925" y="3540345"/>
+            <a:ext cx="11810151" cy="3590925"/>
           </a:xfrm>
           <a:prstGeom prst="rect">
             <a:avLst/>
@@ -7423,18 +7419,18 @@
           <a:p>
             <a:pPr algn="ctr">
               <a:lnSpc>
-                <a:spcPts val="15000"/>
+                <a:spcPts val="14160"/>
               </a:lnSpc>
             </a:pPr>
             <a:r>
-              <a:rPr lang="en-US" sz="12500">
+              <a:rPr lang="en-US" sz="11800">
                 <a:solidFill>
                   <a:srgbClr val="000000"/>
                 </a:solidFill>
-                <a:latin typeface="Jua"/>
-                <a:ea typeface="Jua"/>
-                <a:cs typeface="Jua"/>
-                <a:sym typeface="Jua"/>
+                <a:latin typeface="무궁화 고딕"/>
+                <a:ea typeface="무궁화 고딕"/>
+                <a:cs typeface="무궁화 고딕"/>
+                <a:sym typeface="무궁화 고딕"/>
               </a:rPr>
               <a:t>비행기 안에서</a:t>
             </a:r>
@@ -7442,18 +7438,18 @@
           <a:p>
             <a:pPr algn="ctr">
               <a:lnSpc>
-                <a:spcPts val="15000"/>
+                <a:spcPts val="14160"/>
               </a:lnSpc>
             </a:pPr>
             <a:r>
-              <a:rPr lang="en-US" sz="12500">
+              <a:rPr lang="en-US" sz="11800">
                 <a:solidFill>
                   <a:srgbClr val="000000"/>
                 </a:solidFill>
-                <a:latin typeface="Jua"/>
-                <a:ea typeface="Jua"/>
-                <a:cs typeface="Jua"/>
-                <a:sym typeface="Jua"/>
+                <a:latin typeface="무궁화 고딕"/>
+                <a:ea typeface="무궁화 고딕"/>
+                <a:cs typeface="무궁화 고딕"/>
+                <a:sym typeface="무궁화 고딕"/>
               </a:rPr>
               <a:t>방귀를 더 자주 뀐다</a:t>
             </a:r>
@@ -7550,8 +7546,8 @@
         </p:nvSpPr>
         <p:spPr>
           <a:xfrm rot="0">
-            <a:off x="3238925" y="1263870"/>
-            <a:ext cx="11810151" cy="7429500"/>
+            <a:off x="3238925" y="1978245"/>
+            <a:ext cx="11810151" cy="6715125"/>
           </a:xfrm>
           <a:prstGeom prst="rect">
             <a:avLst/>
@@ -7573,10 +7569,10 @@
                 <a:solidFill>
                   <a:srgbClr val="000000"/>
                 </a:solidFill>
-                <a:latin typeface="Jua"/>
-                <a:ea typeface="Jua"/>
-                <a:cs typeface="Jua"/>
-                <a:sym typeface="Jua"/>
+                <a:latin typeface="무궁화 고딕"/>
+                <a:ea typeface="무궁화 고딕"/>
+                <a:cs typeface="무궁화 고딕"/>
+                <a:sym typeface="무궁화 고딕"/>
               </a:rPr>
               <a:t>O</a:t>
             </a:r>
@@ -7592,10 +7588,10 @@
                 <a:solidFill>
                   <a:srgbClr val="000000"/>
                 </a:solidFill>
-                <a:latin typeface="Jua"/>
-                <a:ea typeface="Jua"/>
-                <a:cs typeface="Jua"/>
-                <a:sym typeface="Jua"/>
+                <a:latin typeface="무궁화 고딕"/>
+                <a:ea typeface="무궁화 고딕"/>
+                <a:cs typeface="무궁화 고딕"/>
+                <a:sym typeface="무궁화 고딕"/>
               </a:rPr>
               <a:t>(기압차 때문)</a:t>
             </a:r>
@@ -7692,8 +7688,8 @@
         </p:nvSpPr>
         <p:spPr>
           <a:xfrm rot="0">
-            <a:off x="3238925" y="3140295"/>
-            <a:ext cx="11810151" cy="4105275"/>
+            <a:off x="3238925" y="3426045"/>
+            <a:ext cx="11810151" cy="3819525"/>
           </a:xfrm>
           <a:prstGeom prst="rect">
             <a:avLst/>
@@ -7715,10 +7711,10 @@
                 <a:solidFill>
                   <a:srgbClr val="000000"/>
                 </a:solidFill>
-                <a:latin typeface="Jua"/>
-                <a:ea typeface="Jua"/>
-                <a:cs typeface="Jua"/>
-                <a:sym typeface="Jua"/>
+                <a:latin typeface="무궁화 고딕"/>
+                <a:ea typeface="무궁화 고딕"/>
+                <a:cs typeface="무궁화 고딕"/>
+                <a:sym typeface="무궁화 고딕"/>
               </a:rPr>
               <a:t>사람의 뇌는 10%만 사용한다</a:t>
             </a:r>
@@ -7815,8 +7811,8 @@
         </p:nvSpPr>
         <p:spPr>
           <a:xfrm rot="0">
-            <a:off x="3238925" y="1263870"/>
-            <a:ext cx="11810151" cy="7429500"/>
+            <a:off x="3238925" y="1978245"/>
+            <a:ext cx="11810151" cy="6715125"/>
           </a:xfrm>
           <a:prstGeom prst="rect">
             <a:avLst/>
@@ -7838,10 +7834,10 @@
                 <a:solidFill>
                   <a:srgbClr val="000000"/>
                 </a:solidFill>
-                <a:latin typeface="Jua"/>
-                <a:ea typeface="Jua"/>
-                <a:cs typeface="Jua"/>
-                <a:sym typeface="Jua"/>
+                <a:latin typeface="무궁화 고딕"/>
+                <a:ea typeface="무궁화 고딕"/>
+                <a:cs typeface="무궁화 고딕"/>
+                <a:sym typeface="무궁화 고딕"/>
               </a:rPr>
               <a:t>X</a:t>
             </a:r>
@@ -7857,10 +7853,10 @@
                 <a:solidFill>
                   <a:srgbClr val="000000"/>
                 </a:solidFill>
-                <a:latin typeface="Jua"/>
-                <a:ea typeface="Jua"/>
-                <a:cs typeface="Jua"/>
-                <a:sym typeface="Jua"/>
+                <a:latin typeface="무궁화 고딕"/>
+                <a:ea typeface="무궁화 고딕"/>
+                <a:cs typeface="무궁화 고딕"/>
+                <a:sym typeface="무궁화 고딕"/>
               </a:rPr>
               <a:t>(대부분 사용)</a:t>
             </a:r>
@@ -7957,8 +7953,8 @@
         </p:nvSpPr>
         <p:spPr>
           <a:xfrm rot="0">
-            <a:off x="3238925" y="3140295"/>
-            <a:ext cx="11810151" cy="4105275"/>
+            <a:off x="3238925" y="3426045"/>
+            <a:ext cx="11810151" cy="3819525"/>
           </a:xfrm>
           <a:prstGeom prst="rect">
             <a:avLst/>
@@ -7980,10 +7976,10 @@
                 <a:solidFill>
                   <a:srgbClr val="000000"/>
                 </a:solidFill>
-                <a:latin typeface="Jua"/>
-                <a:ea typeface="Jua"/>
-                <a:cs typeface="Jua"/>
-                <a:sym typeface="Jua"/>
+                <a:latin typeface="무궁화 고딕"/>
+                <a:ea typeface="무궁화 고딕"/>
+                <a:cs typeface="무궁화 고딕"/>
+                <a:sym typeface="무궁화 고딕"/>
               </a:rPr>
               <a:t>대한민국의 수도는 서울이다</a:t>
             </a:r>
@@ -8080,8 +8076,8 @@
         </p:nvSpPr>
         <p:spPr>
           <a:xfrm rot="0">
-            <a:off x="2378274" y="2943225"/>
-            <a:ext cx="13531452" cy="4105275"/>
+            <a:off x="2378274" y="3305175"/>
+            <a:ext cx="13531452" cy="3667125"/>
           </a:xfrm>
           <a:prstGeom prst="rect">
             <a:avLst/>
@@ -8095,18 +8091,18 @@
           <a:p>
             <a:pPr algn="ctr">
               <a:lnSpc>
-                <a:spcPts val="15000"/>
+                <a:spcPts val="14400"/>
               </a:lnSpc>
             </a:pPr>
             <a:r>
-              <a:rPr lang="en-US" sz="12500">
+              <a:rPr lang="en-US" sz="12000">
                 <a:solidFill>
                   <a:srgbClr val="000000"/>
                 </a:solidFill>
-                <a:latin typeface="Jua"/>
-                <a:ea typeface="Jua"/>
-                <a:cs typeface="Jua"/>
-                <a:sym typeface="Jua"/>
+                <a:latin typeface="무궁화 고딕"/>
+                <a:ea typeface="무궁화 고딕"/>
+                <a:cs typeface="무궁화 고딕"/>
+                <a:sym typeface="무궁화 고딕"/>
               </a:rPr>
               <a:t>번개를 맞을 확률보다 로또 당첨 확률이 높다</a:t>
             </a:r>
@@ -8203,8 +8199,8 @@
         </p:nvSpPr>
         <p:spPr>
           <a:xfrm rot="0">
-            <a:off x="3238925" y="2330670"/>
-            <a:ext cx="11810151" cy="5295900"/>
+            <a:off x="3238925" y="3045045"/>
+            <a:ext cx="11810151" cy="4581525"/>
           </a:xfrm>
           <a:prstGeom prst="rect">
             <a:avLst/>
@@ -8226,10 +8222,10 @@
                 <a:solidFill>
                   <a:srgbClr val="000000"/>
                 </a:solidFill>
-                <a:latin typeface="Jua"/>
-                <a:ea typeface="Jua"/>
-                <a:cs typeface="Jua"/>
-                <a:sym typeface="Jua"/>
+                <a:latin typeface="무궁화 고딕"/>
+                <a:ea typeface="무궁화 고딕"/>
+                <a:cs typeface="무궁화 고딕"/>
+                <a:sym typeface="무궁화 고딕"/>
               </a:rPr>
               <a:t>X</a:t>
             </a:r>
@@ -8326,8 +8322,8 @@
         </p:nvSpPr>
         <p:spPr>
           <a:xfrm rot="0">
-            <a:off x="2968214" y="2943225"/>
-            <a:ext cx="12351572" cy="4105275"/>
+            <a:off x="2968214" y="3400425"/>
+            <a:ext cx="12351572" cy="3476625"/>
           </a:xfrm>
           <a:prstGeom prst="rect">
             <a:avLst/>
@@ -8341,18 +8337,18 @@
           <a:p>
             <a:pPr algn="ctr">
               <a:lnSpc>
-                <a:spcPts val="15000"/>
+                <a:spcPts val="13680"/>
               </a:lnSpc>
             </a:pPr>
             <a:r>
-              <a:rPr lang="en-US" sz="12500">
+              <a:rPr lang="en-US" sz="11400">
                 <a:solidFill>
                   <a:srgbClr val="000000"/>
                 </a:solidFill>
-                <a:latin typeface="Jua"/>
-                <a:ea typeface="Jua"/>
-                <a:cs typeface="Jua"/>
-                <a:sym typeface="Jua"/>
+                <a:latin typeface="무궁화 고딕"/>
+                <a:ea typeface="무궁화 고딕"/>
+                <a:cs typeface="무궁화 고딕"/>
+                <a:sym typeface="무궁화 고딕"/>
               </a:rPr>
               <a:t>스마트폰을 처음 만든 회사는 애플이다</a:t>
             </a:r>
@@ -8449,8 +8445,8 @@
         </p:nvSpPr>
         <p:spPr>
           <a:xfrm rot="0">
-            <a:off x="3238925" y="1263870"/>
-            <a:ext cx="11810151" cy="7429500"/>
+            <a:off x="3238925" y="1978245"/>
+            <a:ext cx="11810151" cy="6715125"/>
           </a:xfrm>
           <a:prstGeom prst="rect">
             <a:avLst/>
@@ -8472,10 +8468,10 @@
                 <a:solidFill>
                   <a:srgbClr val="000000"/>
                 </a:solidFill>
-                <a:latin typeface="Jua"/>
-                <a:ea typeface="Jua"/>
-                <a:cs typeface="Jua"/>
-                <a:sym typeface="Jua"/>
+                <a:latin typeface="무궁화 고딕"/>
+                <a:ea typeface="무궁화 고딕"/>
+                <a:cs typeface="무궁화 고딕"/>
+                <a:sym typeface="무궁화 고딕"/>
               </a:rPr>
               <a:t>X</a:t>
             </a:r>
@@ -8491,10 +8487,10 @@
                 <a:solidFill>
                   <a:srgbClr val="000000"/>
                 </a:solidFill>
-                <a:latin typeface="Jua"/>
-                <a:ea typeface="Jua"/>
-                <a:cs typeface="Jua"/>
-                <a:sym typeface="Jua"/>
+                <a:latin typeface="무궁화 고딕"/>
+                <a:ea typeface="무궁화 고딕"/>
+                <a:cs typeface="무궁화 고딕"/>
+                <a:sym typeface="무궁화 고딕"/>
               </a:rPr>
               <a:t>(IBM)</a:t>
             </a:r>
@@ -8591,8 +8587,8 @@
         </p:nvSpPr>
         <p:spPr>
           <a:xfrm rot="0">
-            <a:off x="1068015" y="2943225"/>
-            <a:ext cx="16151970" cy="4105275"/>
+            <a:off x="1068015" y="3352800"/>
+            <a:ext cx="16151970" cy="3571875"/>
           </a:xfrm>
           <a:prstGeom prst="rect">
             <a:avLst/>
@@ -8606,18 +8602,18 @@
           <a:p>
             <a:pPr algn="ctr">
               <a:lnSpc>
-                <a:spcPts val="15000"/>
+                <a:spcPts val="14040"/>
               </a:lnSpc>
             </a:pPr>
             <a:r>
-              <a:rPr lang="en-US" sz="12500">
+              <a:rPr lang="en-US" sz="11700">
                 <a:solidFill>
                   <a:srgbClr val="000000"/>
                 </a:solidFill>
-                <a:latin typeface="Jua"/>
-                <a:ea typeface="Jua"/>
-                <a:cs typeface="Jua"/>
-                <a:sym typeface="Jua"/>
+                <a:latin typeface="무궁화 고딕"/>
+                <a:ea typeface="무궁화 고딕"/>
+                <a:cs typeface="무궁화 고딕"/>
+                <a:sym typeface="무궁화 고딕"/>
               </a:rPr>
               <a:t>사람의 혈관을 이으면 </a:t>
             </a:r>
@@ -8625,18 +8621,18 @@
           <a:p>
             <a:pPr algn="ctr">
               <a:lnSpc>
-                <a:spcPts val="15000"/>
+                <a:spcPts val="14040"/>
               </a:lnSpc>
             </a:pPr>
             <a:r>
-              <a:rPr lang="en-US" sz="12500">
+              <a:rPr lang="en-US" sz="11700">
                 <a:solidFill>
                   <a:srgbClr val="000000"/>
                 </a:solidFill>
-                <a:latin typeface="Jua"/>
-                <a:ea typeface="Jua"/>
-                <a:cs typeface="Jua"/>
-                <a:sym typeface="Jua"/>
+                <a:latin typeface="무궁화 고딕"/>
+                <a:ea typeface="무궁화 고딕"/>
+                <a:cs typeface="무궁화 고딕"/>
+                <a:sym typeface="무궁화 고딕"/>
               </a:rPr>
               <a:t>지구를 2바퀴 반 돌 수 있다</a:t>
             </a:r>
@@ -8733,8 +8729,8 @@
         </p:nvSpPr>
         <p:spPr>
           <a:xfrm rot="0">
-            <a:off x="3238925" y="1263870"/>
-            <a:ext cx="11810151" cy="7429500"/>
+            <a:off x="3238925" y="1978245"/>
+            <a:ext cx="11810151" cy="6715125"/>
           </a:xfrm>
           <a:prstGeom prst="rect">
             <a:avLst/>
@@ -8756,10 +8752,10 @@
                 <a:solidFill>
                   <a:srgbClr val="000000"/>
                 </a:solidFill>
-                <a:latin typeface="Jua"/>
-                <a:ea typeface="Jua"/>
-                <a:cs typeface="Jua"/>
-                <a:sym typeface="Jua"/>
+                <a:latin typeface="무궁화 고딕"/>
+                <a:ea typeface="무궁화 고딕"/>
+                <a:cs typeface="무궁화 고딕"/>
+                <a:sym typeface="무궁화 고딕"/>
               </a:rPr>
               <a:t>O</a:t>
             </a:r>
@@ -8775,10 +8771,10 @@
                 <a:solidFill>
                   <a:srgbClr val="000000"/>
                 </a:solidFill>
-                <a:latin typeface="Jua"/>
-                <a:ea typeface="Jua"/>
-                <a:cs typeface="Jua"/>
-                <a:sym typeface="Jua"/>
+                <a:latin typeface="무궁화 고딕"/>
+                <a:ea typeface="무궁화 고딕"/>
+                <a:cs typeface="무궁화 고딕"/>
+                <a:sym typeface="무궁화 고딕"/>
               </a:rPr>
               <a:t>(약 10만 km)</a:t>
             </a:r>
@@ -8875,8 +8871,8 @@
         </p:nvSpPr>
         <p:spPr>
           <a:xfrm rot="0">
-            <a:off x="3238925" y="3587970"/>
-            <a:ext cx="11810151" cy="3267075"/>
+            <a:off x="3238925" y="3826095"/>
+            <a:ext cx="11810151" cy="3028950"/>
           </a:xfrm>
           <a:prstGeom prst="rect">
             <a:avLst/>
@@ -8898,10 +8894,10 @@
                 <a:solidFill>
                   <a:srgbClr val="000000"/>
                 </a:solidFill>
-                <a:latin typeface="Jua"/>
-                <a:ea typeface="Jua"/>
-                <a:cs typeface="Jua"/>
-                <a:sym typeface="Jua"/>
+                <a:latin typeface="무궁화 고딕"/>
+                <a:ea typeface="무궁화 고딕"/>
+                <a:cs typeface="무궁화 고딕"/>
+                <a:sym typeface="무궁화 고딕"/>
               </a:rPr>
               <a:t>중국의 만리장성은 1만 리(약 4,000km)이다</a:t>
             </a:r>
@@ -8998,8 +8994,8 @@
         </p:nvSpPr>
         <p:spPr>
           <a:xfrm rot="0">
-            <a:off x="3238925" y="1263870"/>
-            <a:ext cx="11810151" cy="7429500"/>
+            <a:off x="3238925" y="1978245"/>
+            <a:ext cx="11810151" cy="6715125"/>
           </a:xfrm>
           <a:prstGeom prst="rect">
             <a:avLst/>
@@ -9021,10 +9017,10 @@
                 <a:solidFill>
                   <a:srgbClr val="000000"/>
                 </a:solidFill>
-                <a:latin typeface="Jua"/>
-                <a:ea typeface="Jua"/>
-                <a:cs typeface="Jua"/>
-                <a:sym typeface="Jua"/>
+                <a:latin typeface="무궁화 고딕"/>
+                <a:ea typeface="무궁화 고딕"/>
+                <a:cs typeface="무궁화 고딕"/>
+                <a:sym typeface="무궁화 고딕"/>
               </a:rPr>
               <a:t>X</a:t>
             </a:r>
@@ -9040,10 +9036,10 @@
                 <a:solidFill>
                   <a:srgbClr val="000000"/>
                 </a:solidFill>
-                <a:latin typeface="Jua"/>
-                <a:ea typeface="Jua"/>
-                <a:cs typeface="Jua"/>
-                <a:sym typeface="Jua"/>
+                <a:latin typeface="무궁화 고딕"/>
+                <a:ea typeface="무궁화 고딕"/>
+                <a:cs typeface="무궁화 고딕"/>
+                <a:sym typeface="무궁화 고딕"/>
               </a:rPr>
               <a:t>(52,990리)</a:t>
             </a:r>
@@ -9140,8 +9136,8 @@
         </p:nvSpPr>
         <p:spPr>
           <a:xfrm rot="0">
-            <a:off x="2767688" y="2943225"/>
-            <a:ext cx="12752624" cy="4105275"/>
+            <a:off x="2767688" y="3343275"/>
+            <a:ext cx="12752624" cy="3590925"/>
           </a:xfrm>
           <a:prstGeom prst="rect">
             <a:avLst/>
@@ -9155,18 +9151,18 @@
           <a:p>
             <a:pPr algn="ctr">
               <a:lnSpc>
-                <a:spcPts val="15000"/>
+                <a:spcPts val="14160"/>
               </a:lnSpc>
             </a:pPr>
             <a:r>
-              <a:rPr lang="en-US" sz="12500">
+              <a:rPr lang="en-US" sz="11800">
                 <a:solidFill>
                   <a:srgbClr val="000000"/>
                 </a:solidFill>
-                <a:latin typeface="Jua"/>
-                <a:ea typeface="Jua"/>
-                <a:cs typeface="Jua"/>
-                <a:sym typeface="Jua"/>
+                <a:latin typeface="무궁화 고딕"/>
+                <a:ea typeface="무궁화 고딕"/>
+                <a:cs typeface="무궁화 고딕"/>
+                <a:sym typeface="무궁화 고딕"/>
               </a:rPr>
               <a:t>바퀴벌레는 머리 없이 며칠 살 수 있다</a:t>
             </a:r>
@@ -9263,8 +9259,8 @@
         </p:nvSpPr>
         <p:spPr>
           <a:xfrm rot="0">
-            <a:off x="3238925" y="1263870"/>
-            <a:ext cx="11810151" cy="7429500"/>
+            <a:off x="3238925" y="1978245"/>
+            <a:ext cx="11810151" cy="6715125"/>
           </a:xfrm>
           <a:prstGeom prst="rect">
             <a:avLst/>
@@ -9286,10 +9282,10 @@
                 <a:solidFill>
                   <a:srgbClr val="000000"/>
                 </a:solidFill>
-                <a:latin typeface="Jua"/>
-                <a:ea typeface="Jua"/>
-                <a:cs typeface="Jua"/>
-                <a:sym typeface="Jua"/>
+                <a:latin typeface="무궁화 고딕"/>
+                <a:ea typeface="무궁화 고딕"/>
+                <a:cs typeface="무궁화 고딕"/>
+                <a:sym typeface="무궁화 고딕"/>
               </a:rPr>
               <a:t>O</a:t>
             </a:r>
@@ -9305,10 +9301,10 @@
                 <a:solidFill>
                   <a:srgbClr val="000000"/>
                 </a:solidFill>
-                <a:latin typeface="Jua"/>
-                <a:ea typeface="Jua"/>
-                <a:cs typeface="Jua"/>
-                <a:sym typeface="Jua"/>
+                <a:latin typeface="무궁화 고딕"/>
+                <a:ea typeface="무궁화 고딕"/>
+                <a:cs typeface="무궁화 고딕"/>
+                <a:sym typeface="무궁화 고딕"/>
               </a:rPr>
               <a:t>(일주일)</a:t>
             </a:r>
@@ -9405,8 +9401,8 @@
         </p:nvSpPr>
         <p:spPr>
           <a:xfrm rot="0">
-            <a:off x="3238925" y="2330670"/>
-            <a:ext cx="11810151" cy="5295900"/>
+            <a:off x="3238925" y="3045045"/>
+            <a:ext cx="11810151" cy="4581525"/>
           </a:xfrm>
           <a:prstGeom prst="rect">
             <a:avLst/>
@@ -9428,10 +9424,10 @@
                 <a:solidFill>
                   <a:srgbClr val="000000"/>
                 </a:solidFill>
-                <a:latin typeface="Jua"/>
-                <a:ea typeface="Jua"/>
-                <a:cs typeface="Jua"/>
-                <a:sym typeface="Jua"/>
+                <a:latin typeface="무궁화 고딕"/>
+                <a:ea typeface="무궁화 고딕"/>
+                <a:cs typeface="무궁화 고딕"/>
+                <a:sym typeface="무궁화 고딕"/>
               </a:rPr>
               <a:t>O</a:t>
             </a:r>
@@ -9528,8 +9524,8 @@
         </p:nvSpPr>
         <p:spPr>
           <a:xfrm rot="0">
-            <a:off x="2677451" y="2943225"/>
-            <a:ext cx="12933098" cy="4105275"/>
+            <a:off x="2677451" y="3324225"/>
+            <a:ext cx="12933098" cy="3629025"/>
           </a:xfrm>
           <a:prstGeom prst="rect">
             <a:avLst/>
@@ -9543,18 +9539,18 @@
           <a:p>
             <a:pPr algn="ctr">
               <a:lnSpc>
-                <a:spcPts val="15000"/>
+                <a:spcPts val="14280"/>
               </a:lnSpc>
             </a:pPr>
             <a:r>
-              <a:rPr lang="en-US" sz="12500">
+              <a:rPr lang="en-US" sz="11900">
                 <a:solidFill>
                   <a:srgbClr val="000000"/>
                 </a:solidFill>
-                <a:latin typeface="Jua"/>
-                <a:ea typeface="Jua"/>
-                <a:cs typeface="Jua"/>
-                <a:sym typeface="Jua"/>
+                <a:latin typeface="무궁화 고딕"/>
+                <a:ea typeface="무궁화 고딕"/>
+                <a:cs typeface="무궁화 고딕"/>
+                <a:sym typeface="무궁화 고딕"/>
               </a:rPr>
               <a:t>여자가 남자보다 눈을 더 자주 깜빡인다</a:t>
             </a:r>
@@ -9651,8 +9647,8 @@
         </p:nvSpPr>
         <p:spPr>
           <a:xfrm rot="0">
-            <a:off x="3238925" y="1263870"/>
-            <a:ext cx="11810151" cy="7429500"/>
+            <a:off x="3238925" y="1978245"/>
+            <a:ext cx="11810151" cy="6715125"/>
           </a:xfrm>
           <a:prstGeom prst="rect">
             <a:avLst/>
@@ -9674,10 +9670,10 @@
                 <a:solidFill>
                   <a:srgbClr val="000000"/>
                 </a:solidFill>
-                <a:latin typeface="Jua"/>
-                <a:ea typeface="Jua"/>
-                <a:cs typeface="Jua"/>
-                <a:sym typeface="Jua"/>
+                <a:latin typeface="무궁화 고딕"/>
+                <a:ea typeface="무궁화 고딕"/>
+                <a:cs typeface="무궁화 고딕"/>
+                <a:sym typeface="무궁화 고딕"/>
               </a:rPr>
               <a:t>O</a:t>
             </a:r>
@@ -9693,10 +9689,10 @@
                 <a:solidFill>
                   <a:srgbClr val="000000"/>
                 </a:solidFill>
-                <a:latin typeface="Jua"/>
-                <a:ea typeface="Jua"/>
-                <a:cs typeface="Jua"/>
-                <a:sym typeface="Jua"/>
+                <a:latin typeface="무궁화 고딕"/>
+                <a:ea typeface="무궁화 고딕"/>
+                <a:cs typeface="무궁화 고딕"/>
+                <a:sym typeface="무궁화 고딕"/>
               </a:rPr>
               <a:t>(약 2배)</a:t>
             </a:r>
@@ -9793,8 +9789,8 @@
         </p:nvSpPr>
         <p:spPr>
           <a:xfrm rot="0">
-            <a:off x="3238925" y="3140295"/>
-            <a:ext cx="11810151" cy="4105275"/>
+            <a:off x="3238925" y="3549870"/>
+            <a:ext cx="11810151" cy="3571875"/>
           </a:xfrm>
           <a:prstGeom prst="rect">
             <a:avLst/>
@@ -9808,18 +9804,18 @@
           <a:p>
             <a:pPr algn="ctr">
               <a:lnSpc>
-                <a:spcPts val="15000"/>
+                <a:spcPts val="14040"/>
               </a:lnSpc>
             </a:pPr>
             <a:r>
-              <a:rPr lang="en-US" sz="12500">
+              <a:rPr lang="en-US" sz="11700">
                 <a:solidFill>
                   <a:srgbClr val="000000"/>
                 </a:solidFill>
-                <a:latin typeface="Jua"/>
-                <a:ea typeface="Jua"/>
-                <a:cs typeface="Jua"/>
-                <a:sym typeface="Jua"/>
+                <a:latin typeface="무궁화 고딕"/>
+                <a:ea typeface="무궁화 고딕"/>
+                <a:cs typeface="무궁화 고딕"/>
+                <a:sym typeface="무궁화 고딕"/>
               </a:rPr>
               <a:t>잠을 안 자면 배고픈 것보다 먼저 죽는다</a:t>
             </a:r>
@@ -9916,8 +9912,8 @@
         </p:nvSpPr>
         <p:spPr>
           <a:xfrm rot="0">
-            <a:off x="3238925" y="2330670"/>
-            <a:ext cx="11810151" cy="5295900"/>
+            <a:off x="3238925" y="3045045"/>
+            <a:ext cx="11810151" cy="4581525"/>
           </a:xfrm>
           <a:prstGeom prst="rect">
             <a:avLst/>
@@ -9939,10 +9935,10 @@
                 <a:solidFill>
                   <a:srgbClr val="000000"/>
                 </a:solidFill>
-                <a:latin typeface="Jua"/>
-                <a:ea typeface="Jua"/>
-                <a:cs typeface="Jua"/>
-                <a:sym typeface="Jua"/>
+                <a:latin typeface="무궁화 고딕"/>
+                <a:ea typeface="무궁화 고딕"/>
+                <a:cs typeface="무궁화 고딕"/>
+                <a:sym typeface="무궁화 고딕"/>
               </a:rPr>
               <a:t>O</a:t>
             </a:r>
@@ -10039,8 +10035,8 @@
         </p:nvSpPr>
         <p:spPr>
           <a:xfrm rot="0">
-            <a:off x="3238925" y="3140295"/>
-            <a:ext cx="11810151" cy="4105275"/>
+            <a:off x="3238925" y="3492720"/>
+            <a:ext cx="11810151" cy="3686175"/>
           </a:xfrm>
           <a:prstGeom prst="rect">
             <a:avLst/>
@@ -10054,18 +10050,18 @@
           <a:p>
             <a:pPr algn="ctr">
               <a:lnSpc>
-                <a:spcPts val="15000"/>
+                <a:spcPts val="14520"/>
               </a:lnSpc>
             </a:pPr>
             <a:r>
-              <a:rPr lang="en-US" sz="12500">
+              <a:rPr lang="en-US" sz="12100">
                 <a:solidFill>
                   <a:srgbClr val="000000"/>
                 </a:solidFill>
-                <a:latin typeface="Jua"/>
-                <a:ea typeface="Jua"/>
-                <a:cs typeface="Jua"/>
-                <a:sym typeface="Jua"/>
+                <a:latin typeface="무궁화 고딕"/>
+                <a:ea typeface="무궁화 고딕"/>
+                <a:cs typeface="무궁화 고딕"/>
+                <a:sym typeface="무궁화 고딕"/>
               </a:rPr>
               <a:t>바다의 95%는 아직 탐사되지 않았다</a:t>
             </a:r>
@@ -10162,8 +10158,8 @@
         </p:nvSpPr>
         <p:spPr>
           <a:xfrm rot="0">
-            <a:off x="3238925" y="2330670"/>
-            <a:ext cx="11810151" cy="5295900"/>
+            <a:off x="3238925" y="3045045"/>
+            <a:ext cx="11810151" cy="4581525"/>
           </a:xfrm>
           <a:prstGeom prst="rect">
             <a:avLst/>
@@ -10185,10 +10181,10 @@
                 <a:solidFill>
                   <a:srgbClr val="000000"/>
                 </a:solidFill>
-                <a:latin typeface="Jua"/>
-                <a:ea typeface="Jua"/>
-                <a:cs typeface="Jua"/>
-                <a:sym typeface="Jua"/>
+                <a:latin typeface="무궁화 고딕"/>
+                <a:ea typeface="무궁화 고딕"/>
+                <a:cs typeface="무궁화 고딕"/>
+                <a:sym typeface="무궁화 고딕"/>
               </a:rPr>
               <a:t>O</a:t>
             </a:r>
@@ -10285,8 +10281,8 @@
         </p:nvSpPr>
         <p:spPr>
           <a:xfrm rot="0">
-            <a:off x="3238925" y="3140295"/>
-            <a:ext cx="11810151" cy="4105275"/>
+            <a:off x="3238925" y="3426045"/>
+            <a:ext cx="11810151" cy="3819525"/>
           </a:xfrm>
           <a:prstGeom prst="rect">
             <a:avLst/>
@@ -10308,10 +10304,10 @@
                 <a:solidFill>
                   <a:srgbClr val="000000"/>
                 </a:solidFill>
-                <a:latin typeface="Jua"/>
-                <a:ea typeface="Jua"/>
-                <a:cs typeface="Jua"/>
-                <a:sym typeface="Jua"/>
+                <a:latin typeface="무궁화 고딕"/>
+                <a:ea typeface="무궁화 고딕"/>
+                <a:cs typeface="무궁화 고딕"/>
+                <a:sym typeface="무궁화 고딕"/>
               </a:rPr>
               <a:t>올림픽 금메달은</a:t>
             </a:r>
@@ -10327,10 +10323,10 @@
                 <a:solidFill>
                   <a:srgbClr val="000000"/>
                 </a:solidFill>
-                <a:latin typeface="Jua"/>
-                <a:ea typeface="Jua"/>
-                <a:cs typeface="Jua"/>
-                <a:sym typeface="Jua"/>
+                <a:latin typeface="무궁화 고딕"/>
+                <a:ea typeface="무궁화 고딕"/>
+                <a:cs typeface="무궁화 고딕"/>
+                <a:sym typeface="무궁화 고딕"/>
               </a:rPr>
               <a:t>순금이다</a:t>
             </a:r>
@@ -10427,8 +10423,8 @@
         </p:nvSpPr>
         <p:spPr>
           <a:xfrm rot="0">
-            <a:off x="3238925" y="1263870"/>
-            <a:ext cx="11810151" cy="7429500"/>
+            <a:off x="3238925" y="1978245"/>
+            <a:ext cx="11810151" cy="6715125"/>
           </a:xfrm>
           <a:prstGeom prst="rect">
             <a:avLst/>
@@ -10450,10 +10446,10 @@
                 <a:solidFill>
                   <a:srgbClr val="000000"/>
                 </a:solidFill>
-                <a:latin typeface="Jua"/>
-                <a:ea typeface="Jua"/>
-                <a:cs typeface="Jua"/>
-                <a:sym typeface="Jua"/>
+                <a:latin typeface="무궁화 고딕"/>
+                <a:ea typeface="무궁화 고딕"/>
+                <a:cs typeface="무궁화 고딕"/>
+                <a:sym typeface="무궁화 고딕"/>
               </a:rPr>
               <a:t>X</a:t>
             </a:r>
@@ -10469,10 +10465,10 @@
                 <a:solidFill>
                   <a:srgbClr val="000000"/>
                 </a:solidFill>
-                <a:latin typeface="Jua"/>
-                <a:ea typeface="Jua"/>
-                <a:cs typeface="Jua"/>
-                <a:sym typeface="Jua"/>
+                <a:latin typeface="무궁화 고딕"/>
+                <a:ea typeface="무궁화 고딕"/>
+                <a:cs typeface="무궁화 고딕"/>
+                <a:sym typeface="무궁화 고딕"/>
               </a:rPr>
               <a:t>(은에 금도금)</a:t>
             </a:r>
@@ -10569,8 +10565,8 @@
         </p:nvSpPr>
         <p:spPr>
           <a:xfrm rot="0">
-            <a:off x="1704898" y="3180641"/>
-            <a:ext cx="14878203" cy="3629025"/>
+            <a:off x="1704898" y="3447341"/>
+            <a:ext cx="14878203" cy="3362325"/>
           </a:xfrm>
           <a:prstGeom prst="rect">
             <a:avLst/>
@@ -10592,10 +10588,10 @@
                 <a:solidFill>
                   <a:srgbClr val="000000"/>
                 </a:solidFill>
-                <a:latin typeface="Jua"/>
-                <a:ea typeface="Jua"/>
-                <a:cs typeface="Jua"/>
-                <a:sym typeface="Jua"/>
+                <a:latin typeface="무궁화 고딕"/>
+                <a:ea typeface="무궁화 고딕"/>
+                <a:cs typeface="무궁화 고딕"/>
+                <a:sym typeface="무궁화 고딕"/>
               </a:rPr>
               <a:t>100원짜리 동전을 만드는 데 100원 이상 든다</a:t>
             </a:r>
@@ -10692,8 +10688,8 @@
         </p:nvSpPr>
         <p:spPr>
           <a:xfrm rot="0">
-            <a:off x="3238925" y="2330670"/>
-            <a:ext cx="11810151" cy="5295900"/>
+            <a:off x="3238925" y="3045045"/>
+            <a:ext cx="11810151" cy="4581525"/>
           </a:xfrm>
           <a:prstGeom prst="rect">
             <a:avLst/>
@@ -10715,10 +10711,10 @@
                 <a:solidFill>
                   <a:srgbClr val="000000"/>
                 </a:solidFill>
-                <a:latin typeface="Jua"/>
-                <a:ea typeface="Jua"/>
-                <a:cs typeface="Jua"/>
-                <a:sym typeface="Jua"/>
+                <a:latin typeface="무궁화 고딕"/>
+                <a:ea typeface="무궁화 고딕"/>
+                <a:cs typeface="무궁화 고딕"/>
+                <a:sym typeface="무궁화 고딕"/>
               </a:rPr>
               <a:t>O</a:t>
             </a:r>
@@ -10815,8 +10811,8 @@
         </p:nvSpPr>
         <p:spPr>
           <a:xfrm rot="0">
-            <a:off x="3238925" y="3140295"/>
-            <a:ext cx="11810151" cy="4105275"/>
+            <a:off x="3238925" y="3473670"/>
+            <a:ext cx="11810151" cy="3724275"/>
           </a:xfrm>
           <a:prstGeom prst="rect">
             <a:avLst/>
@@ -10830,18 +10826,18 @@
           <a:p>
             <a:pPr algn="ctr">
               <a:lnSpc>
-                <a:spcPts val="15000"/>
+                <a:spcPts val="14640"/>
               </a:lnSpc>
             </a:pPr>
             <a:r>
-              <a:rPr lang="en-US" sz="12500">
+              <a:rPr lang="en-US" sz="12200">
                 <a:solidFill>
                   <a:srgbClr val="000000"/>
                 </a:solidFill>
-                <a:latin typeface="Jua"/>
-                <a:ea typeface="Jua"/>
-                <a:cs typeface="Jua"/>
-                <a:sym typeface="Jua"/>
+                <a:latin typeface="무궁화 고딕"/>
+                <a:ea typeface="무궁화 고딕"/>
+                <a:cs typeface="무궁화 고딕"/>
+                <a:sym typeface="무궁화 고딕"/>
               </a:rPr>
               <a:t>태양계에서 가장 큰 행성은 목성이다</a:t>
             </a:r>
@@ -10938,8 +10934,8 @@
         </p:nvSpPr>
         <p:spPr>
           <a:xfrm rot="0">
-            <a:off x="3238925" y="3140295"/>
-            <a:ext cx="11810151" cy="4105275"/>
+            <a:off x="3238925" y="3426045"/>
+            <a:ext cx="11810151" cy="3819525"/>
           </a:xfrm>
           <a:prstGeom prst="rect">
             <a:avLst/>
@@ -10961,10 +10957,10 @@
                 <a:solidFill>
                   <a:srgbClr val="000000"/>
                 </a:solidFill>
-                <a:latin typeface="Jua"/>
-                <a:ea typeface="Jua"/>
-                <a:cs typeface="Jua"/>
-                <a:sym typeface="Jua"/>
+                <a:latin typeface="무궁화 고딕"/>
+                <a:ea typeface="무궁화 고딕"/>
+                <a:cs typeface="무궁화 고딕"/>
+                <a:sym typeface="무궁화 고딕"/>
               </a:rPr>
               <a:t>돌고래는 한쪽 눈만 감고 잔다</a:t>
             </a:r>
@@ -11061,8 +11057,8 @@
         </p:nvSpPr>
         <p:spPr>
           <a:xfrm rot="0">
-            <a:off x="3238925" y="1263870"/>
-            <a:ext cx="11810151" cy="7429500"/>
+            <a:off x="3238925" y="1978245"/>
+            <a:ext cx="11810151" cy="6715125"/>
           </a:xfrm>
           <a:prstGeom prst="rect">
             <a:avLst/>
@@ -11084,10 +11080,10 @@
                 <a:solidFill>
                   <a:srgbClr val="000000"/>
                 </a:solidFill>
-                <a:latin typeface="Jua"/>
-                <a:ea typeface="Jua"/>
-                <a:cs typeface="Jua"/>
-                <a:sym typeface="Jua"/>
+                <a:latin typeface="무궁화 고딕"/>
+                <a:ea typeface="무궁화 고딕"/>
+                <a:cs typeface="무궁화 고딕"/>
+                <a:sym typeface="무궁화 고딕"/>
               </a:rPr>
               <a:t>O</a:t>
             </a:r>
@@ -11103,10 +11099,10 @@
                 <a:solidFill>
                   <a:srgbClr val="000000"/>
                 </a:solidFill>
-                <a:latin typeface="Jua"/>
-                <a:ea typeface="Jua"/>
-                <a:cs typeface="Jua"/>
-                <a:sym typeface="Jua"/>
+                <a:latin typeface="무궁화 고딕"/>
+                <a:ea typeface="무궁화 고딕"/>
+                <a:cs typeface="무궁화 고딕"/>
+                <a:sym typeface="무궁화 고딕"/>
               </a:rPr>
               <a:t>(반구 수면)</a:t>
             </a:r>
@@ -11203,8 +11199,8 @@
         </p:nvSpPr>
         <p:spPr>
           <a:xfrm rot="0">
-            <a:off x="3238925" y="3140295"/>
-            <a:ext cx="11810151" cy="4105275"/>
+            <a:off x="3238925" y="3426045"/>
+            <a:ext cx="11810151" cy="3819525"/>
           </a:xfrm>
           <a:prstGeom prst="rect">
             <a:avLst/>
@@ -11226,10 +11222,10 @@
                 <a:solidFill>
                   <a:srgbClr val="000000"/>
                 </a:solidFill>
-                <a:latin typeface="Jua"/>
-                <a:ea typeface="Jua"/>
-                <a:cs typeface="Jua"/>
-                <a:sym typeface="Jua"/>
+                <a:latin typeface="무궁화 고딕"/>
+                <a:ea typeface="무궁화 고딕"/>
+                <a:cs typeface="무궁화 고딕"/>
+                <a:sym typeface="무궁화 고딕"/>
               </a:rPr>
               <a:t>타이타닉에는</a:t>
             </a:r>
@@ -11245,10 +11241,10 @@
                 <a:solidFill>
                   <a:srgbClr val="000000"/>
                 </a:solidFill>
-                <a:latin typeface="Jua"/>
-                <a:ea typeface="Jua"/>
-                <a:cs typeface="Jua"/>
-                <a:sym typeface="Jua"/>
+                <a:latin typeface="무궁화 고딕"/>
+                <a:ea typeface="무궁화 고딕"/>
+                <a:cs typeface="무궁화 고딕"/>
+                <a:sym typeface="무궁화 고딕"/>
               </a:rPr>
               <a:t>수영장이 있었다</a:t>
             </a:r>
@@ -11345,8 +11341,8 @@
         </p:nvSpPr>
         <p:spPr>
           <a:xfrm rot="0">
-            <a:off x="3238925" y="2330670"/>
-            <a:ext cx="11810151" cy="5295900"/>
+            <a:off x="3238925" y="3045045"/>
+            <a:ext cx="11810151" cy="4581525"/>
           </a:xfrm>
           <a:prstGeom prst="rect">
             <a:avLst/>
@@ -11368,10 +11364,10 @@
                 <a:solidFill>
                   <a:srgbClr val="000000"/>
                 </a:solidFill>
-                <a:latin typeface="Jua"/>
-                <a:ea typeface="Jua"/>
-                <a:cs typeface="Jua"/>
-                <a:sym typeface="Jua"/>
+                <a:latin typeface="무궁화 고딕"/>
+                <a:ea typeface="무궁화 고딕"/>
+                <a:cs typeface="무궁화 고딕"/>
+                <a:sym typeface="무궁화 고딕"/>
               </a:rPr>
               <a:t>O</a:t>
             </a:r>
@@ -11493,8 +11489,8 @@
         </p:nvSpPr>
         <p:spPr>
           <a:xfrm rot="0">
-            <a:off x="4421807" y="3895725"/>
-            <a:ext cx="9444385" cy="2200275"/>
+            <a:off x="4421807" y="4181475"/>
+            <a:ext cx="9444385" cy="1914525"/>
           </a:xfrm>
           <a:prstGeom prst="rect">
             <a:avLst/>
@@ -11516,10 +11512,10 @@
                 <a:solidFill>
                   <a:srgbClr val="000000"/>
                 </a:solidFill>
-                <a:latin typeface="Jua"/>
-                <a:ea typeface="Jua"/>
-                <a:cs typeface="Jua"/>
-                <a:sym typeface="Jua"/>
+                <a:latin typeface="무궁화 고딕"/>
+                <a:ea typeface="무궁화 고딕"/>
+                <a:cs typeface="무궁화 고딕"/>
+                <a:sym typeface="무궁화 고딕"/>
               </a:rPr>
               <a:t>감사합니다!</a:t>
             </a:r>
@@ -11616,8 +11612,8 @@
         </p:nvSpPr>
         <p:spPr>
           <a:xfrm rot="0">
-            <a:off x="3238925" y="2330670"/>
-            <a:ext cx="11810151" cy="5295900"/>
+            <a:off x="3238925" y="3045045"/>
+            <a:ext cx="11810151" cy="4581525"/>
           </a:xfrm>
           <a:prstGeom prst="rect">
             <a:avLst/>
@@ -11639,10 +11635,10 @@
                 <a:solidFill>
                   <a:srgbClr val="000000"/>
                 </a:solidFill>
-                <a:latin typeface="Jua"/>
-                <a:ea typeface="Jua"/>
-                <a:cs typeface="Jua"/>
-                <a:sym typeface="Jua"/>
+                <a:latin typeface="무궁화 고딕"/>
+                <a:ea typeface="무궁화 고딕"/>
+                <a:cs typeface="무궁화 고딕"/>
+                <a:sym typeface="무궁화 고딕"/>
               </a:rPr>
               <a:t>O</a:t>
             </a:r>
@@ -11739,8 +11735,8 @@
         </p:nvSpPr>
         <p:spPr>
           <a:xfrm rot="0">
-            <a:off x="3238925" y="3140295"/>
-            <a:ext cx="11810151" cy="4105275"/>
+            <a:off x="3238925" y="3426045"/>
+            <a:ext cx="11810151" cy="3819525"/>
           </a:xfrm>
           <a:prstGeom prst="rect">
             <a:avLst/>
@@ -11762,10 +11758,10 @@
                 <a:solidFill>
                   <a:srgbClr val="000000"/>
                 </a:solidFill>
-                <a:latin typeface="Jua"/>
-                <a:ea typeface="Jua"/>
-                <a:cs typeface="Jua"/>
-                <a:sym typeface="Jua"/>
+                <a:latin typeface="무궁화 고딕"/>
+                <a:ea typeface="무궁화 고딕"/>
+                <a:cs typeface="무궁화 고딕"/>
+                <a:sym typeface="무궁화 고딕"/>
               </a:rPr>
               <a:t>지구에서 가장 큰</a:t>
             </a:r>
@@ -11781,10 +11777,10 @@
                 <a:solidFill>
                   <a:srgbClr val="000000"/>
                 </a:solidFill>
-                <a:latin typeface="Jua"/>
-                <a:ea typeface="Jua"/>
-                <a:cs typeface="Jua"/>
-                <a:sym typeface="Jua"/>
+                <a:latin typeface="무궁화 고딕"/>
+                <a:ea typeface="무궁화 고딕"/>
+                <a:cs typeface="무궁화 고딕"/>
+                <a:sym typeface="무궁화 고딕"/>
               </a:rPr>
               <a:t>대륙은 아시아이다</a:t>
             </a:r>
@@ -11881,8 +11877,8 @@
         </p:nvSpPr>
         <p:spPr>
           <a:xfrm rot="0">
-            <a:off x="3238925" y="2330670"/>
-            <a:ext cx="11810151" cy="5295900"/>
+            <a:off x="3238925" y="3045045"/>
+            <a:ext cx="11810151" cy="4581525"/>
           </a:xfrm>
           <a:prstGeom prst="rect">
             <a:avLst/>
@@ -11904,10 +11900,10 @@
                 <a:solidFill>
                   <a:srgbClr val="000000"/>
                 </a:solidFill>
-                <a:latin typeface="Jua"/>
-                <a:ea typeface="Jua"/>
-                <a:cs typeface="Jua"/>
-                <a:sym typeface="Jua"/>
+                <a:latin typeface="무궁화 고딕"/>
+                <a:ea typeface="무궁화 고딕"/>
+                <a:cs typeface="무궁화 고딕"/>
+                <a:sym typeface="무궁화 고딕"/>
               </a:rPr>
               <a:t>O</a:t>
             </a:r>

</xml_diff>